<commit_message>
Form 3 L25, L28: move definitions out of step/cause lists in the board summary
Co-Authored-By: Claude Opus 5.5 <noreply@anthropic.com>
Claude-Session: https://claude.ai/code/session_0115LFSb2ktGLWPeVksFkSer
</commit_message>
<xml_diff>
--- a/lecons/F3/29_FORM4_LESSON25_Depositional_Features_of_Wave_Action.pptx
+++ b/lecons/F3/29_FORM4_LESSON25_Depositional_Features_of_Wave_Action.pptx
@@ -50,9 +50,10 @@
     <p:sldId id="298" r:id="rId44"/>
     <p:sldId id="299" r:id="rId45"/>
     <p:sldId id="300" r:id="rId46"/>
+    <p:sldId id="301" r:id="rId47"/>
   </p:sldIdLst>
   <p:notesMasterIdLst>
-    <p:notesMasterId r:id="rId47"/>
+    <p:notesMasterId r:id="rId48"/>
   </p:notesMasterIdLst>
   <p:sldSz cx="12192000" cy="6858000"/>
   <p:notesSz cx="6858000" cy="12192000"/>
@@ -2306,7 +2307,7 @@
           <a:p>
             <a:r>
               <a:rPr lang="en-US" dirty="0"/>
-              <a:t>Let us copy Longshore Drift. Longshore drift takes place in the following steps. On this slide we have Meaning and Step 1. Write each point on a new line, with the key term first, and explain it in your own words when we revise. When you finish, we go to the next slide.</a:t>
+              <a:t>Let us copy the definitions. The key terms of this lesson are defined as follows. On this slide we have Longshore drift and Deposition. Write each point on a new line, with the key term first, and explain it in your own words when we revise.</a:t>
             </a:r>
             <a:endParaRPr lang="en-US" dirty="0"/>
           </a:p>
@@ -2394,7 +2395,7 @@
           <a:p>
             <a:r>
               <a:rPr lang="en-US" dirty="0"/>
-              <a:t>We continue with Longshore Drift. On this slide we have Step 2 and Step 3. Write each point on a new line, with the key term first, and explain it in your own words when we revise.</a:t>
+              <a:t>Let us copy Longshore Drift. Longshore drift takes place in the following steps. On this slide we have Step 1 and Step 2. Write each point on a new line, with the key term first, and explain it in your own words when we revise. When you finish, we go to the next slide.</a:t>
             </a:r>
             <a:endParaRPr lang="en-US" dirty="0"/>
           </a:p>
@@ -2570,7 +2571,7 @@
           <a:p>
             <a:r>
               <a:rPr lang="en-US" dirty="0"/>
-              <a:t>Now draw this illustration in your notebook: longshore drift. Give it a title and label it clearly.</a:t>
+              <a:t>We continue with Longshore Drift. On this slide we have Step 3. Write each point on a new line, with the key term first, and explain it in your own words when we revise.</a:t>
             </a:r>
             <a:endParaRPr lang="en-US" dirty="0"/>
           </a:p>
@@ -2658,7 +2659,7 @@
           <a:p>
             <a:r>
               <a:rPr lang="en-US" dirty="0"/>
-              <a:t>Let us copy Depositional Features. Wave deposition forms the following features. On this slide we have Beach and Spit. Write each point on a new line, with the key term first, and explain it in your own words when we revise. When you finish, we go to the next slide.</a:t>
+              <a:t>Now draw this illustration in your notebook: longshore drift. Give it a title and label it clearly.</a:t>
             </a:r>
             <a:endParaRPr lang="en-US" dirty="0"/>
           </a:p>
@@ -2746,7 +2747,7 @@
           <a:p>
             <a:r>
               <a:rPr lang="en-US" dirty="0"/>
-              <a:t>We continue with Depositional Features. On this slide we have Bar and Tombolo. Write each point on a new line, with the key term first, and explain it in your own words when we revise.</a:t>
+              <a:t>Let us copy Depositional Features. Wave deposition forms the following features. On this slide we have Beach and Spit. Write each point on a new line, with the key term first, and explain it in your own words when we revise. When you finish, we go to the next slide.</a:t>
             </a:r>
             <a:endParaRPr lang="en-US" dirty="0"/>
           </a:p>
@@ -2834,7 +2835,7 @@
           <a:p>
             <a:r>
               <a:rPr lang="en-US" dirty="0"/>
-              <a:t>Now let us check what you have understood. Question 1: What is longshore drift? Answer in your exercise book.</a:t>
+              <a:t>We continue with Depositional Features. On this slide we have Bar and Tombolo. Write each point on a new line, with the key term first, and explain it in your own words when we revise.</a:t>
             </a:r>
             <a:endParaRPr lang="en-US" dirty="0"/>
           </a:p>
@@ -2922,7 +2923,7 @@
           <a:p>
             <a:r>
               <a:rPr lang="en-US" dirty="0"/>
-              <a:t>The expected answer is: the movement of sand along the beach by waves. If you got it right, well done.</a:t>
+              <a:t>Now let us check what you have understood. Question 1: What is longshore drift? Answer in your exercise book.</a:t>
             </a:r>
             <a:endParaRPr lang="en-US" dirty="0"/>
           </a:p>
@@ -3010,7 +3011,7 @@
           <a:p>
             <a:r>
               <a:rPr lang="en-US" dirty="0"/>
-              <a:t>Now let us check what you have understood. Question 2: What is the difference between a spit and a bar? Answer in your exercise book.</a:t>
+              <a:t>The expected answer is: the movement of sand along the beach by waves. If you got it right, well done.</a:t>
             </a:r>
             <a:endParaRPr lang="en-US" dirty="0"/>
           </a:p>
@@ -3098,7 +3099,7 @@
           <a:p>
             <a:r>
               <a:rPr lang="en-US" dirty="0"/>
-              <a:t>The expected answer is: a spit is joined at one end; a bar closes a bay. If you got it right, well done.</a:t>
+              <a:t>Now let us check what you have understood. Question 2: What is the difference between a spit and a bar? Answer in your exercise book.</a:t>
             </a:r>
             <a:endParaRPr lang="en-US" dirty="0"/>
           </a:p>
@@ -3186,7 +3187,7 @@
           <a:p>
             <a:r>
               <a:rPr lang="en-US" dirty="0"/>
-              <a:t>Take your time to copy this part; we will continue together.</a:t>
+              <a:t>The expected answer is: a spit is joined at one end; a bar closes a bay. If you got it right, well done.</a:t>
             </a:r>
             <a:endParaRPr lang="en-US" dirty="0"/>
           </a:p>
@@ -3274,7 +3275,7 @@
           <a:p>
             <a:r>
               <a:rPr lang="en-US" dirty="0"/>
-              <a:t>For those who need more practice, fill in the blanks in your exercise book. The answers are: number 1, longshore; number 2, spit; number 3, tombolo.</a:t>
+              <a:t>Take your time to copy this part; we will continue together.</a:t>
             </a:r>
             <a:endParaRPr lang="en-US" dirty="0"/>
           </a:p>
@@ -3362,7 +3363,7 @@
           <a:p>
             <a:r>
               <a:rPr lang="en-US" dirty="0"/>
-              <a:t>For your homework: List five goods sold in the market of Garoua that come from abroad. Ask a trader through which port they entered Cameroon. We shall correct it at the beginning of our next lesson.</a:t>
+              <a:t>For those who need more practice, fill in the blanks in your exercise book. The answers are: number 1, longshore; number 2, spit; number 3, tombolo.</a:t>
             </a:r>
             <a:endParaRPr lang="en-US" dirty="0"/>
           </a:p>
@@ -3538,7 +3539,7 @@
           <a:p>
             <a:r>
               <a:rPr lang="en-US" dirty="0"/>
-              <a:t>Our next lesson will be on Lesson 26: Impact of Wave Action on Human Development along Coastal Areas. Thank you for your attention, and see you next time.</a:t>
+              <a:t>For your homework: List five goods sold in the market of Garoua that come from abroad. Ask a trader through which port they entered Cameroon. We shall correct it at the beginning of our next lesson.</a:t>
             </a:r>
             <a:endParaRPr lang="en-US" dirty="0"/>
           </a:p>
@@ -3626,7 +3627,7 @@
           <a:p>
             <a:r>
               <a:rPr lang="en-US" dirty="0"/>
-              <a:t>Let us play the bilingual game. I say a word in English, and you give me the French word. Then we do the reverse.</a:t>
+              <a:t>Our next lesson will be on Lesson 26: Impact of Wave Action on Human Development along Coastal Areas. Thank you for your attention, and see you next time.</a:t>
             </a:r>
             <a:endParaRPr lang="en-US" dirty="0"/>
           </a:p>
@@ -3714,7 +3715,7 @@
           <a:p>
             <a:r>
               <a:rPr lang="en-US" dirty="0"/>
-              <a:t>I record this information in the official logbook of the class after the lesson.</a:t>
+              <a:t>Let us play the bilingual game. I say a word in English, and you give me the French word. Then we do the reverse.</a:t>
             </a:r>
             <a:endParaRPr lang="en-US" dirty="0"/>
           </a:p>
@@ -3802,7 +3803,7 @@
           <a:p>
             <a:r>
               <a:rPr lang="en-US" dirty="0"/>
-              <a:t>I complete the second page of the logbook: the matter taught, the evaluation, the homework and the attendance.</a:t>
+              <a:t>I record this information in the official logbook of the class after the lesson.</a:t>
             </a:r>
             <a:endParaRPr lang="en-US" dirty="0"/>
           </a:p>
@@ -3890,7 +3891,7 @@
           <a:p>
             <a:r>
               <a:rPr lang="en-US" dirty="0"/>
-              <a:t>This slide is for me, the teacher: it gives the timing of the lesson and what to do if the projector is not available.</a:t>
+              <a:t>I complete the second page of the logbook: the matter taught, the evaluation, the homework and the attendance.</a:t>
             </a:r>
             <a:endParaRPr lang="en-US" dirty="0"/>
           </a:p>
@@ -3978,7 +3979,7 @@
           <a:p>
             <a:r>
               <a:rPr lang="en-US" dirty="0"/>
-              <a:t>These are the references and picture credits used to prepare this lesson.</a:t>
+              <a:t>This slide is for me, the teacher: it gives the timing of the lesson and what to do if the projector is not available.</a:t>
             </a:r>
             <a:endParaRPr lang="en-US" dirty="0"/>
           </a:p>
@@ -4002,6 +4003,94 @@
             <a:fld id="{F7021451-1387-4CA6-816F-3879F97B5CBC}" type="slidenum">
               <a:rPr lang="en-US"/>
               <a:t>45</a:t>
+            </a:fld>
+            <a:endParaRPr lang="en-US"/>
+          </a:p>
+        </p:txBody>
+      </p:sp>
+    </p:spTree>
+    <p:extLst>
+      <p:ext uri="{BB962C8B-B14F-4D97-AF65-F5344CB8AC3E}">
+        <p14:creationId xmlns:p14="http://schemas.microsoft.com/office/powerpoint/2010/main" val="1024086991"/>
+      </p:ext>
+    </p:extLst>
+  </p:cSld>
+  <p:clrMapOvr>
+    <a:masterClrMapping/>
+  </p:clrMapOvr>
+</p:notes>
+</file>
+
+<file path=ppt/notesSlides/notesSlide46.xml><?xml version="1.0" encoding="utf-8"?>
+<p:notes xmlns:a="http://schemas.openxmlformats.org/drawingml/2006/main" xmlns:r="http://schemas.openxmlformats.org/officeDocument/2006/relationships" xmlns:p="http://schemas.openxmlformats.org/presentationml/2006/main">
+  <p:cSld>
+    <p:spTree>
+      <p:nvGrpSpPr>
+        <p:cNvPr id="1" name=""/>
+        <p:cNvGrpSpPr/>
+        <p:nvPr/>
+      </p:nvGrpSpPr>
+      <p:grpSpPr>
+        <a:xfrm>
+          <a:off x="0" y="0"/>
+          <a:ext cx="0" cy="0"/>
+          <a:chOff x="0" y="0"/>
+          <a:chExt cx="0" cy="0"/>
+        </a:xfrm>
+      </p:grpSpPr>
+      <p:sp>
+        <p:nvSpPr>
+          <p:cNvPr id="2" name="Slide Image Placeholder 1"/>
+          <p:cNvSpPr>
+            <a:spLocks noGrp="1" noRot="1" noChangeAspect="1"/>
+          </p:cNvSpPr>
+          <p:nvPr>
+            <p:ph type="sldImg"/>
+          </p:nvPr>
+        </p:nvSpPr>
+        <p:spPr/>
+      </p:sp>
+      <p:sp>
+        <p:nvSpPr>
+          <p:cNvPr id="3" name="Notes Placeholder 2"/>
+          <p:cNvSpPr>
+            <a:spLocks noGrp="1"/>
+          </p:cNvSpPr>
+          <p:nvPr>
+            <p:ph type="body" idx="1"/>
+          </p:nvPr>
+        </p:nvSpPr>
+        <p:spPr/>
+        <p:txBody>
+          <a:bodyPr/>
+          <a:lstStyle/>
+          <a:p>
+            <a:r>
+              <a:rPr lang="en-US" dirty="0"/>
+              <a:t>These are the references and picture credits used to prepare this lesson.</a:t>
+            </a:r>
+            <a:endParaRPr lang="en-US" dirty="0"/>
+          </a:p>
+        </p:txBody>
+      </p:sp>
+      <p:sp>
+        <p:nvSpPr>
+          <p:cNvPr id="4" name="Slide Number Placeholder 3"/>
+          <p:cNvSpPr>
+            <a:spLocks noGrp="1"/>
+          </p:cNvSpPr>
+          <p:nvPr>
+            <p:ph type="sldNum" sz="quarter" idx="10"/>
+          </p:nvPr>
+        </p:nvSpPr>
+        <p:spPr/>
+        <p:txBody>
+          <a:bodyPr/>
+          <a:lstStyle/>
+          <a:p>
+            <a:fld id="{F7021451-1387-4CA6-816F-3879F97B5CBC}" type="slidenum">
+              <a:rPr lang="en-US"/>
+              <a:t>46</a:t>
             </a:fld>
             <a:endParaRPr lang="en-US"/>
           </a:p>
@@ -10360,7 +10449,7 @@
         <p:spPr>
           <a:xfrm>
             <a:off x="0" y="658368"/>
-            <a:ext cx="3840480" cy="5833872"/>
+            <a:ext cx="1463040" cy="5833872"/>
           </a:xfrm>
           <a:prstGeom prst="rect">
             <a:avLst/>
@@ -10375,8 +10464,8 @@
         </p:nvSpPr>
         <p:spPr>
           <a:xfrm>
-            <a:off x="4069080" y="1005840"/>
-            <a:ext cx="7802575" cy="731520"/>
+            <a:off x="1691640" y="1005840"/>
+            <a:ext cx="10180015" cy="731520"/>
           </a:xfrm>
           <a:prstGeom prst="rect">
             <a:avLst/>
@@ -10402,7 +10491,7 @@
                 <a:ea typeface="Times New Roman" pitchFamily="34" charset="-122"/>
                 <a:cs typeface="Times New Roman" pitchFamily="34" charset="-120"/>
               </a:rPr>
-              <a:t>1. Longshore Drift</a:t>
+              <a:t>DEFINITIONS</a:t>
             </a:r>
             <a:endParaRPr lang="en-US" sz="3600" dirty="0"/>
           </a:p>
@@ -10416,8 +10505,8 @@
         </p:nvSpPr>
         <p:spPr>
           <a:xfrm>
-            <a:off x="4069080" y="1783080"/>
-            <a:ext cx="7802575" cy="4663440"/>
+            <a:off x="1691640" y="1783080"/>
+            <a:ext cx="10180015" cy="4663440"/>
           </a:xfrm>
           <a:prstGeom prst="rect">
             <a:avLst/>
@@ -10444,7 +10533,7 @@
                 <a:ea typeface="Times New Roman" pitchFamily="34" charset="-122"/>
                 <a:cs typeface="Times New Roman" pitchFamily="34" charset="-120"/>
               </a:rPr>
-              <a:t>Longshore drift takes place in the following steps:</a:t>
+              <a:t>The key terms of this lesson are defined as follows:</a:t>
             </a:r>
             <a:endParaRPr lang="en-US" sz="4000" dirty="0"/>
           </a:p>
@@ -10464,7 +10553,7 @@
                 <a:ea typeface="Times New Roman" pitchFamily="34" charset="-122"/>
                 <a:cs typeface="Times New Roman" pitchFamily="34" charset="-120"/>
               </a:rPr>
-              <a:t>Meaning: </a:t>
+              <a:t>Longshore drift: </a:t>
             </a:r>
             <a:pPr algn="l" indent="0" marL="0">
               <a:spcAft>
@@ -10481,7 +10570,7 @@
                 <a:ea typeface="Times New Roman" pitchFamily="34" charset="-122"/>
                 <a:cs typeface="Times New Roman" pitchFamily="34" charset="-120"/>
               </a:rPr>
-              <a:t>Longshore drift is the movement of sand and pebbles along the coast by waves.</a:t>
+              <a:t>It is the movement of sand and pebbles along the coast by waves.</a:t>
             </a:r>
             <a:endParaRPr lang="en-US" sz="4000" dirty="0"/>
           </a:p>
@@ -10501,7 +10590,7 @@
                 <a:ea typeface="Times New Roman" pitchFamily="34" charset="-122"/>
                 <a:cs typeface="Times New Roman" pitchFamily="34" charset="-120"/>
               </a:rPr>
-              <a:t>Step 1: </a:t>
+              <a:t>Deposition: </a:t>
             </a:r>
             <a:pPr algn="l" indent="0" marL="0">
               <a:spcAft>
@@ -10518,7 +10607,7 @@
                 <a:ea typeface="Times New Roman" pitchFamily="34" charset="-122"/>
                 <a:cs typeface="Times New Roman" pitchFamily="34" charset="-120"/>
               </a:rPr>
-              <a:t>Waves reach the beach at an angle because of the wind.</a:t>
+              <a:t>It is the dropping of sand and pebbles by waves when they lose energy.</a:t>
             </a:r>
             <a:endParaRPr lang="en-US" sz="4000" dirty="0"/>
           </a:p>
@@ -10653,7 +10742,7 @@
         <p:spPr>
           <a:xfrm>
             <a:off x="0" y="658368"/>
-            <a:ext cx="5120640" cy="5833872"/>
+            <a:ext cx="3840480" cy="5833872"/>
           </a:xfrm>
           <a:prstGeom prst="rect">
             <a:avLst/>
@@ -10668,8 +10757,8 @@
         </p:nvSpPr>
         <p:spPr>
           <a:xfrm>
-            <a:off x="5349240" y="1005840"/>
-            <a:ext cx="6522415" cy="731520"/>
+            <a:off x="4069080" y="1005840"/>
+            <a:ext cx="7802575" cy="731520"/>
           </a:xfrm>
           <a:prstGeom prst="rect">
             <a:avLst/>
@@ -10695,7 +10784,7 @@
                 <a:ea typeface="Times New Roman" pitchFamily="34" charset="-122"/>
                 <a:cs typeface="Times New Roman" pitchFamily="34" charset="-120"/>
               </a:rPr>
-              <a:t>1. Longshore Drift (continued)</a:t>
+              <a:t>1. Longshore Drift</a:t>
             </a:r>
             <a:endParaRPr lang="en-US" sz="3600" dirty="0"/>
           </a:p>
@@ -10709,8 +10798,8 @@
         </p:nvSpPr>
         <p:spPr>
           <a:xfrm>
-            <a:off x="5349240" y="1783080"/>
-            <a:ext cx="6522415" cy="4663440"/>
+            <a:off x="4069080" y="1783080"/>
+            <a:ext cx="7802575" cy="4663440"/>
           </a:xfrm>
           <a:prstGeom prst="rect">
             <a:avLst/>
@@ -10729,7 +10818,7 @@
               <a:buNone/>
             </a:pPr>
             <a:r>
-              <a:rPr lang="en-US" sz="4000" b="1" dirty="0">
+              <a:rPr lang="en-US" sz="4000" i="1" dirty="0">
                 <a:solidFill>
                   <a:srgbClr val="111111"/>
                 </a:solidFill>
@@ -10737,8 +10826,11 @@
                 <a:ea typeface="Times New Roman" pitchFamily="34" charset="-122"/>
                 <a:cs typeface="Times New Roman" pitchFamily="34" charset="-120"/>
               </a:rPr>
-              <a:t>Step 2: </a:t>
-            </a:r>
+              <a:t>Longshore drift takes place in the following steps:</a:t>
+            </a:r>
+            <a:endParaRPr lang="en-US" sz="4000" dirty="0"/>
+          </a:p>
+          <a:p>
             <a:pPr algn="l" indent="0" marL="0">
               <a:spcAft>
                 <a:spcPts val="800"/>
@@ -10746,7 +10838,7 @@
               <a:buNone/>
             </a:pPr>
             <a:r>
-              <a:rPr lang="en-US" sz="4000" dirty="0">
+              <a:rPr lang="en-US" sz="4000" b="1" dirty="0">
                 <a:solidFill>
                   <a:srgbClr val="111111"/>
                 </a:solidFill>
@@ -10754,11 +10846,8 @@
                 <a:ea typeface="Times New Roman" pitchFamily="34" charset="-122"/>
                 <a:cs typeface="Times New Roman" pitchFamily="34" charset="-120"/>
               </a:rPr>
-              <a:t>The swash pushes sand up the beach at the same angle.</a:t>
-            </a:r>
-            <a:endParaRPr lang="en-US" sz="4000" dirty="0"/>
-          </a:p>
-          <a:p>
+              <a:t>Step 1: </a:t>
+            </a:r>
             <a:pPr algn="l" indent="0" marL="0">
               <a:spcAft>
                 <a:spcPts val="800"/>
@@ -10766,7 +10855,7 @@
               <a:buNone/>
             </a:pPr>
             <a:r>
-              <a:rPr lang="en-US" sz="4000" b="1" dirty="0">
+              <a:rPr lang="en-US" sz="4000" dirty="0">
                 <a:solidFill>
                   <a:srgbClr val="111111"/>
                 </a:solidFill>
@@ -10774,8 +10863,11 @@
                 <a:ea typeface="Times New Roman" pitchFamily="34" charset="-122"/>
                 <a:cs typeface="Times New Roman" pitchFamily="34" charset="-120"/>
               </a:rPr>
-              <a:t>Step 3: </a:t>
-            </a:r>
+              <a:t>Waves reach the beach at an angle because of the wind.</a:t>
+            </a:r>
+            <a:endParaRPr lang="en-US" sz="4000" dirty="0"/>
+          </a:p>
+          <a:p>
             <a:pPr algn="l" indent="0" marL="0">
               <a:spcAft>
                 <a:spcPts val="800"/>
@@ -10783,7 +10875,7 @@
               <a:buNone/>
             </a:pPr>
             <a:r>
-              <a:rPr lang="en-US" sz="4000" dirty="0">
+              <a:rPr lang="en-US" sz="4000" b="1" dirty="0">
                 <a:solidFill>
                   <a:srgbClr val="111111"/>
                 </a:solidFill>
@@ -10791,7 +10883,24 @@
                 <a:ea typeface="Times New Roman" pitchFamily="34" charset="-122"/>
                 <a:cs typeface="Times New Roman" pitchFamily="34" charset="-120"/>
               </a:rPr>
-              <a:t>The backwash brings the sand straight back down, so it moves along the beach in zigzags.</a:t>
+              <a:t>Step 2: </a:t>
+            </a:r>
+            <a:pPr algn="l" indent="0" marL="0">
+              <a:spcAft>
+                <a:spcPts val="800"/>
+              </a:spcAft>
+              <a:buNone/>
+            </a:pPr>
+            <a:r>
+              <a:rPr lang="en-US" sz="4000" dirty="0">
+                <a:solidFill>
+                  <a:srgbClr val="111111"/>
+                </a:solidFill>
+                <a:latin typeface="Times New Roman" pitchFamily="34" charset="0"/>
+                <a:ea typeface="Times New Roman" pitchFamily="34" charset="-122"/>
+                <a:cs typeface="Times New Roman" pitchFamily="34" charset="-120"/>
+              </a:rPr>
+              <a:t>The swash pushes sand up the beach at the same angle.</a:t>
             </a:r>
             <a:endParaRPr lang="en-US" sz="4000" dirty="0"/>
           </a:p>
@@ -11918,48 +12027,9 @@
           </a:p>
         </p:txBody>
       </p:sp>
-      <p:sp>
-        <p:nvSpPr>
-          <p:cNvPr id="3" name="Text 1"/>
-          <p:cNvSpPr/>
-          <p:nvPr/>
-        </p:nvSpPr>
-        <p:spPr>
-          <a:xfrm>
-            <a:off x="457200" y="1005840"/>
-            <a:ext cx="11277295" cy="731520"/>
-          </a:xfrm>
-          <a:prstGeom prst="rect">
-            <a:avLst/>
-          </a:prstGeom>
-          <a:noFill/>
-          <a:ln/>
-        </p:spPr>
-        <p:txBody>
-          <a:bodyPr wrap="square" lIns="0" tIns="0" rIns="0" bIns="0" rtlCol="0" anchor="ctr"/>
-          <a:lstStyle/>
-          <a:p>
-            <a:pPr algn="ctr" indent="0" marL="0">
-              <a:buNone/>
-            </a:pPr>
-            <a:r>
-              <a:rPr lang="en-US" sz="3600" b="1" dirty="0">
-                <a:solidFill>
-                  <a:srgbClr val="990011"/>
-                </a:solidFill>
-                <a:latin typeface="Times New Roman" pitchFamily="34" charset="0"/>
-                <a:ea typeface="Times New Roman" pitchFamily="34" charset="-122"/>
-                <a:cs typeface="Times New Roman" pitchFamily="34" charset="-120"/>
-              </a:rPr>
-              <a:t>1. Longshore Drift</a:t>
-            </a:r>
-            <a:endParaRPr lang="en-US" sz="3600" dirty="0"/>
-          </a:p>
-        </p:txBody>
-      </p:sp>
       <p:pic>
         <p:nvPicPr>
-          <p:cNvPr id="4" name="Image 0" descr="/home/claude/f4/img/v2/longshore_last.png">    </p:cNvPr>
+          <p:cNvPr id="3" name="Image 0" descr="/home/claude/f4/img/minesec_sheet.png">    </p:cNvPr>
           <p:cNvPicPr>
             <a:picLocks noChangeAspect="1"/>
           </p:cNvPicPr>
@@ -11973,8 +12043,8 @@
         </p:blipFill>
         <p:spPr>
           <a:xfrm>
-            <a:off x="629930" y="1783080"/>
-            <a:ext cx="10931835" cy="4270248"/>
+            <a:off x="0" y="658368"/>
+            <a:ext cx="5120640" cy="5833872"/>
           </a:xfrm>
           <a:prstGeom prst="rect">
             <a:avLst/>
@@ -11983,14 +12053,14 @@
       </p:pic>
       <p:sp>
         <p:nvSpPr>
-          <p:cNvPr id="5" name="Text 2"/>
+          <p:cNvPr id="4" name="Text 1"/>
           <p:cNvSpPr/>
           <p:nvPr/>
         </p:nvSpPr>
         <p:spPr>
           <a:xfrm>
-            <a:off x="457200" y="6089904"/>
-            <a:ext cx="11277295" cy="347472"/>
+            <a:off x="5349240" y="1005840"/>
+            <a:ext cx="6522415" cy="731520"/>
           </a:xfrm>
           <a:prstGeom prst="rect">
             <a:avLst/>
@@ -11999,24 +12069,85 @@
           <a:ln/>
         </p:spPr>
         <p:txBody>
-          <a:bodyPr wrap="square" lIns="0" tIns="0" rIns="0" bIns="0" rtlCol="0" anchor="ctr"/>
+          <a:bodyPr wrap="square" lIns="0" tIns="0" rIns="0" bIns="0" rtlCol="0" anchor="ctr">
+            <a:normAutofit/>
+          </a:bodyPr>
           <a:lstStyle/>
           <a:p>
             <a:pPr algn="ctr" indent="0" marL="0">
               <a:buNone/>
             </a:pPr>
             <a:r>
-              <a:rPr lang="en-US" sz="1800" i="1" dirty="0">
-                <a:solidFill>
-                  <a:srgbClr val="555555"/>
+              <a:rPr lang="en-US" sz="3600" b="1" dirty="0">
+                <a:solidFill>
+                  <a:srgbClr val="990011"/>
                 </a:solidFill>
                 <a:latin typeface="Times New Roman" pitchFamily="34" charset="0"/>
                 <a:ea typeface="Times New Roman" pitchFamily="34" charset="-122"/>
                 <a:cs typeface="Times New Roman" pitchFamily="34" charset="-120"/>
               </a:rPr>
-              <a:t>Illustration: longshore drift</a:t>
-            </a:r>
-            <a:endParaRPr lang="en-US" sz="1800" dirty="0"/>
+              <a:t>1. Longshore Drift (continued)</a:t>
+            </a:r>
+            <a:endParaRPr lang="en-US" sz="3600" dirty="0"/>
+          </a:p>
+        </p:txBody>
+      </p:sp>
+      <p:sp>
+        <p:nvSpPr>
+          <p:cNvPr id="5" name="Text 2"/>
+          <p:cNvSpPr/>
+          <p:nvPr/>
+        </p:nvSpPr>
+        <p:spPr>
+          <a:xfrm>
+            <a:off x="5349240" y="1783080"/>
+            <a:ext cx="6522415" cy="4663440"/>
+          </a:xfrm>
+          <a:prstGeom prst="rect">
+            <a:avLst/>
+          </a:prstGeom>
+          <a:noFill/>
+          <a:ln/>
+        </p:spPr>
+        <p:txBody>
+          <a:bodyPr wrap="square" lIns="0" tIns="0" rIns="0" bIns="0" rtlCol="0" anchor="t"/>
+          <a:lstStyle/>
+          <a:p>
+            <a:pPr algn="l" indent="0" marL="0">
+              <a:spcAft>
+                <a:spcPts val="800"/>
+              </a:spcAft>
+              <a:buNone/>
+            </a:pPr>
+            <a:r>
+              <a:rPr lang="en-US" sz="4000" b="1" dirty="0">
+                <a:solidFill>
+                  <a:srgbClr val="111111"/>
+                </a:solidFill>
+                <a:latin typeface="Times New Roman" pitchFamily="34" charset="0"/>
+                <a:ea typeface="Times New Roman" pitchFamily="34" charset="-122"/>
+                <a:cs typeface="Times New Roman" pitchFamily="34" charset="-120"/>
+              </a:rPr>
+              <a:t>Step 3: </a:t>
+            </a:r>
+            <a:pPr algn="l" indent="0" marL="0">
+              <a:spcAft>
+                <a:spcPts val="800"/>
+              </a:spcAft>
+              <a:buNone/>
+            </a:pPr>
+            <a:r>
+              <a:rPr lang="en-US" sz="4000" dirty="0">
+                <a:solidFill>
+                  <a:srgbClr val="111111"/>
+                </a:solidFill>
+                <a:latin typeface="Times New Roman" pitchFamily="34" charset="0"/>
+                <a:ea typeface="Times New Roman" pitchFamily="34" charset="-122"/>
+                <a:cs typeface="Times New Roman" pitchFamily="34" charset="-120"/>
+              </a:rPr>
+              <a:t>The backwash brings the sand straight back down, so it moves along the beach in zigzags.</a:t>
+            </a:r>
+            <a:endParaRPr lang="en-US" sz="4000" dirty="0"/>
           </a:p>
         </p:txBody>
       </p:sp>
@@ -12132,9 +12263,48 @@
           </a:p>
         </p:txBody>
       </p:sp>
+      <p:sp>
+        <p:nvSpPr>
+          <p:cNvPr id="3" name="Text 1"/>
+          <p:cNvSpPr/>
+          <p:nvPr/>
+        </p:nvSpPr>
+        <p:spPr>
+          <a:xfrm>
+            <a:off x="457200" y="1005840"/>
+            <a:ext cx="11277295" cy="731520"/>
+          </a:xfrm>
+          <a:prstGeom prst="rect">
+            <a:avLst/>
+          </a:prstGeom>
+          <a:noFill/>
+          <a:ln/>
+        </p:spPr>
+        <p:txBody>
+          <a:bodyPr wrap="square" lIns="0" tIns="0" rIns="0" bIns="0" rtlCol="0" anchor="ctr"/>
+          <a:lstStyle/>
+          <a:p>
+            <a:pPr algn="ctr" indent="0" marL="0">
+              <a:buNone/>
+            </a:pPr>
+            <a:r>
+              <a:rPr lang="en-US" sz="3600" b="1" dirty="0">
+                <a:solidFill>
+                  <a:srgbClr val="990011"/>
+                </a:solidFill>
+                <a:latin typeface="Times New Roman" pitchFamily="34" charset="0"/>
+                <a:ea typeface="Times New Roman" pitchFamily="34" charset="-122"/>
+                <a:cs typeface="Times New Roman" pitchFamily="34" charset="-120"/>
+              </a:rPr>
+              <a:t>1. Longshore Drift</a:t>
+            </a:r>
+            <a:endParaRPr lang="en-US" sz="3600" dirty="0"/>
+          </a:p>
+        </p:txBody>
+      </p:sp>
       <p:pic>
         <p:nvPicPr>
-          <p:cNvPr id="3" name="Image 0" descr="/home/claude/f4/img/minesec_sheet.png">    </p:cNvPr>
+          <p:cNvPr id="4" name="Image 0" descr="/home/claude/f4/img/v2/longshore_last.png">    </p:cNvPr>
           <p:cNvPicPr>
             <a:picLocks noChangeAspect="1"/>
           </p:cNvPicPr>
@@ -12148,8 +12318,8 @@
         </p:blipFill>
         <p:spPr>
           <a:xfrm>
-            <a:off x="0" y="658368"/>
-            <a:ext cx="2468880" cy="5833872"/>
+            <a:off x="629930" y="1783080"/>
+            <a:ext cx="10931835" cy="4270248"/>
           </a:xfrm>
           <a:prstGeom prst="rect">
             <a:avLst/>
@@ -12158,14 +12328,14 @@
       </p:pic>
       <p:sp>
         <p:nvSpPr>
-          <p:cNvPr id="4" name="Text 1"/>
+          <p:cNvPr id="5" name="Text 2"/>
           <p:cNvSpPr/>
           <p:nvPr/>
         </p:nvSpPr>
         <p:spPr>
           <a:xfrm>
-            <a:off x="2697480" y="1005840"/>
-            <a:ext cx="9174175" cy="731520"/>
+            <a:off x="457200" y="6089904"/>
+            <a:ext cx="11277295" cy="347472"/>
           </a:xfrm>
           <a:prstGeom prst="rect">
             <a:avLst/>
@@ -12174,142 +12344,24 @@
           <a:ln/>
         </p:spPr>
         <p:txBody>
-          <a:bodyPr wrap="square" lIns="0" tIns="0" rIns="0" bIns="0" rtlCol="0" anchor="ctr">
-            <a:normAutofit/>
-          </a:bodyPr>
+          <a:bodyPr wrap="square" lIns="0" tIns="0" rIns="0" bIns="0" rtlCol="0" anchor="ctr"/>
           <a:lstStyle/>
           <a:p>
             <a:pPr algn="ctr" indent="0" marL="0">
               <a:buNone/>
             </a:pPr>
             <a:r>
-              <a:rPr lang="en-US" sz="3600" b="1" dirty="0">
-                <a:solidFill>
-                  <a:srgbClr val="990011"/>
+              <a:rPr lang="en-US" sz="1800" i="1" dirty="0">
+                <a:solidFill>
+                  <a:srgbClr val="555555"/>
                 </a:solidFill>
                 <a:latin typeface="Times New Roman" pitchFamily="34" charset="0"/>
                 <a:ea typeface="Times New Roman" pitchFamily="34" charset="-122"/>
                 <a:cs typeface="Times New Roman" pitchFamily="34" charset="-120"/>
               </a:rPr>
-              <a:t>2. Depositional Features</a:t>
-            </a:r>
-            <a:endParaRPr lang="en-US" sz="3600" dirty="0"/>
-          </a:p>
-        </p:txBody>
-      </p:sp>
-      <p:sp>
-        <p:nvSpPr>
-          <p:cNvPr id="5" name="Text 2"/>
-          <p:cNvSpPr/>
-          <p:nvPr/>
-        </p:nvSpPr>
-        <p:spPr>
-          <a:xfrm>
-            <a:off x="2697480" y="1783080"/>
-            <a:ext cx="9174175" cy="4663440"/>
-          </a:xfrm>
-          <a:prstGeom prst="rect">
-            <a:avLst/>
-          </a:prstGeom>
-          <a:noFill/>
-          <a:ln/>
-        </p:spPr>
-        <p:txBody>
-          <a:bodyPr wrap="square" lIns="0" tIns="0" rIns="0" bIns="0" rtlCol="0" anchor="t"/>
-          <a:lstStyle/>
-          <a:p>
-            <a:pPr algn="l" indent="0" marL="0">
-              <a:spcAft>
-                <a:spcPts val="800"/>
-              </a:spcAft>
-              <a:buNone/>
-            </a:pPr>
-            <a:r>
-              <a:rPr lang="en-US" sz="4000" i="1" dirty="0">
-                <a:solidFill>
-                  <a:srgbClr val="111111"/>
-                </a:solidFill>
-                <a:latin typeface="Times New Roman" pitchFamily="34" charset="0"/>
-                <a:ea typeface="Times New Roman" pitchFamily="34" charset="-122"/>
-                <a:cs typeface="Times New Roman" pitchFamily="34" charset="-120"/>
-              </a:rPr>
-              <a:t>Wave deposition forms the following features:</a:t>
-            </a:r>
-            <a:endParaRPr lang="en-US" sz="4000" dirty="0"/>
-          </a:p>
-          <a:p>
-            <a:pPr algn="l" indent="0" marL="0">
-              <a:spcAft>
-                <a:spcPts val="800"/>
-              </a:spcAft>
-              <a:buNone/>
-            </a:pPr>
-            <a:r>
-              <a:rPr lang="en-US" sz="4000" b="1" dirty="0">
-                <a:solidFill>
-                  <a:srgbClr val="111111"/>
-                </a:solidFill>
-                <a:latin typeface="Times New Roman" pitchFamily="34" charset="0"/>
-                <a:ea typeface="Times New Roman" pitchFamily="34" charset="-122"/>
-                <a:cs typeface="Times New Roman" pitchFamily="34" charset="-120"/>
-              </a:rPr>
-              <a:t>Beach: </a:t>
-            </a:r>
-            <a:pPr algn="l" indent="0" marL="0">
-              <a:spcAft>
-                <a:spcPts val="800"/>
-              </a:spcAft>
-              <a:buNone/>
-            </a:pPr>
-            <a:r>
-              <a:rPr lang="en-US" sz="4000" dirty="0">
-                <a:solidFill>
-                  <a:srgbClr val="111111"/>
-                </a:solidFill>
-                <a:latin typeface="Times New Roman" pitchFamily="34" charset="0"/>
-                <a:ea typeface="Times New Roman" pitchFamily="34" charset="-122"/>
-                <a:cs typeface="Times New Roman" pitchFamily="34" charset="-120"/>
-              </a:rPr>
-              <a:t>It is a gentle slope of sand and pebbles between low and high tide, like the beaches of Kribi.</a:t>
-            </a:r>
-            <a:endParaRPr lang="en-US" sz="4000" dirty="0"/>
-          </a:p>
-          <a:p>
-            <a:pPr algn="l" indent="0" marL="0">
-              <a:spcAft>
-                <a:spcPts val="800"/>
-              </a:spcAft>
-              <a:buNone/>
-            </a:pPr>
-            <a:r>
-              <a:rPr lang="en-US" sz="4000" b="1" dirty="0">
-                <a:solidFill>
-                  <a:srgbClr val="111111"/>
-                </a:solidFill>
-                <a:latin typeface="Times New Roman" pitchFamily="34" charset="0"/>
-                <a:ea typeface="Times New Roman" pitchFamily="34" charset="-122"/>
-                <a:cs typeface="Times New Roman" pitchFamily="34" charset="-120"/>
-              </a:rPr>
-              <a:t>Spit: </a:t>
-            </a:r>
-            <a:pPr algn="l" indent="0" marL="0">
-              <a:spcAft>
-                <a:spcPts val="800"/>
-              </a:spcAft>
-              <a:buNone/>
-            </a:pPr>
-            <a:r>
-              <a:rPr lang="en-US" sz="4000" dirty="0">
-                <a:solidFill>
-                  <a:srgbClr val="111111"/>
-                </a:solidFill>
-                <a:latin typeface="Times New Roman" pitchFamily="34" charset="0"/>
-                <a:ea typeface="Times New Roman" pitchFamily="34" charset="-122"/>
-                <a:cs typeface="Times New Roman" pitchFamily="34" charset="-120"/>
-              </a:rPr>
-              <a:t>It is a long strip of sand joined to the land at one end.</a:t>
-            </a:r>
-            <a:endParaRPr lang="en-US" sz="4000" dirty="0"/>
+              <a:t>Illustration: longshore drift</a:t>
+            </a:r>
+            <a:endParaRPr lang="en-US" sz="1800" dirty="0"/>
           </a:p>
         </p:txBody>
       </p:sp>
@@ -12442,7 +12494,7 @@
         <p:spPr>
           <a:xfrm>
             <a:off x="0" y="658368"/>
-            <a:ext cx="5120640" cy="5833872"/>
+            <a:ext cx="2468880" cy="5833872"/>
           </a:xfrm>
           <a:prstGeom prst="rect">
             <a:avLst/>
@@ -12457,8 +12509,8 @@
         </p:nvSpPr>
         <p:spPr>
           <a:xfrm>
-            <a:off x="5349240" y="1005840"/>
-            <a:ext cx="6522415" cy="731520"/>
+            <a:off x="2697480" y="1005840"/>
+            <a:ext cx="9174175" cy="731520"/>
           </a:xfrm>
           <a:prstGeom prst="rect">
             <a:avLst/>
@@ -12484,7 +12536,7 @@
                 <a:ea typeface="Times New Roman" pitchFamily="34" charset="-122"/>
                 <a:cs typeface="Times New Roman" pitchFamily="34" charset="-120"/>
               </a:rPr>
-              <a:t>2. Depositional Features (continued)</a:t>
+              <a:t>2. Depositional Features</a:t>
             </a:r>
             <a:endParaRPr lang="en-US" sz="3600" dirty="0"/>
           </a:p>
@@ -12498,8 +12550,8 @@
         </p:nvSpPr>
         <p:spPr>
           <a:xfrm>
-            <a:off x="5349240" y="1783080"/>
-            <a:ext cx="6522415" cy="4663440"/>
+            <a:off x="2697480" y="1783080"/>
+            <a:ext cx="9174175" cy="4663440"/>
           </a:xfrm>
           <a:prstGeom prst="rect">
             <a:avLst/>
@@ -12518,7 +12570,7 @@
               <a:buNone/>
             </a:pPr>
             <a:r>
-              <a:rPr lang="en-US" sz="4000" b="1" dirty="0">
+              <a:rPr lang="en-US" sz="4000" i="1" dirty="0">
                 <a:solidFill>
                   <a:srgbClr val="111111"/>
                 </a:solidFill>
@@ -12526,8 +12578,11 @@
                 <a:ea typeface="Times New Roman" pitchFamily="34" charset="-122"/>
                 <a:cs typeface="Times New Roman" pitchFamily="34" charset="-120"/>
               </a:rPr>
-              <a:t>Bar: </a:t>
-            </a:r>
+              <a:t>Wave deposition forms the following features:</a:t>
+            </a:r>
+            <a:endParaRPr lang="en-US" sz="4000" dirty="0"/>
+          </a:p>
+          <a:p>
             <a:pPr algn="l" indent="0" marL="0">
               <a:spcAft>
                 <a:spcPts val="800"/>
@@ -12535,7 +12590,7 @@
               <a:buNone/>
             </a:pPr>
             <a:r>
-              <a:rPr lang="en-US" sz="4000" dirty="0">
+              <a:rPr lang="en-US" sz="4000" b="1" dirty="0">
                 <a:solidFill>
                   <a:srgbClr val="111111"/>
                 </a:solidFill>
@@ -12543,11 +12598,8 @@
                 <a:ea typeface="Times New Roman" pitchFamily="34" charset="-122"/>
                 <a:cs typeface="Times New Roman" pitchFamily="34" charset="-120"/>
               </a:rPr>
-              <a:t>It is a strip of sand that grows across a bay.</a:t>
-            </a:r>
-            <a:endParaRPr lang="en-US" sz="4000" dirty="0"/>
-          </a:p>
-          <a:p>
+              <a:t>Beach: </a:t>
+            </a:r>
             <a:pPr algn="l" indent="0" marL="0">
               <a:spcAft>
                 <a:spcPts val="800"/>
@@ -12555,7 +12607,7 @@
               <a:buNone/>
             </a:pPr>
             <a:r>
-              <a:rPr lang="en-US" sz="4000" b="1" dirty="0">
+              <a:rPr lang="en-US" sz="4000" dirty="0">
                 <a:solidFill>
                   <a:srgbClr val="111111"/>
                 </a:solidFill>
@@ -12563,8 +12615,11 @@
                 <a:ea typeface="Times New Roman" pitchFamily="34" charset="-122"/>
                 <a:cs typeface="Times New Roman" pitchFamily="34" charset="-120"/>
               </a:rPr>
-              <a:t>Tombolo: </a:t>
-            </a:r>
+              <a:t>It is a gentle slope of sand and pebbles between low and high tide, like the beaches of Kribi.</a:t>
+            </a:r>
+            <a:endParaRPr lang="en-US" sz="4000" dirty="0"/>
+          </a:p>
+          <a:p>
             <a:pPr algn="l" indent="0" marL="0">
               <a:spcAft>
                 <a:spcPts val="800"/>
@@ -12572,7 +12627,7 @@
               <a:buNone/>
             </a:pPr>
             <a:r>
-              <a:rPr lang="en-US" sz="4000" dirty="0">
+              <a:rPr lang="en-US" sz="4000" b="1" dirty="0">
                 <a:solidFill>
                   <a:srgbClr val="111111"/>
                 </a:solidFill>
@@ -12580,7 +12635,24 @@
                 <a:ea typeface="Times New Roman" pitchFamily="34" charset="-122"/>
                 <a:cs typeface="Times New Roman" pitchFamily="34" charset="-120"/>
               </a:rPr>
-              <a:t>It is a strip of sand that joins an island to the mainland.</a:t>
+              <a:t>Spit: </a:t>
+            </a:r>
+            <a:pPr algn="l" indent="0" marL="0">
+              <a:spcAft>
+                <a:spcPts val="800"/>
+              </a:spcAft>
+              <a:buNone/>
+            </a:pPr>
+            <a:r>
+              <a:rPr lang="en-US" sz="4000" dirty="0">
+                <a:solidFill>
+                  <a:srgbClr val="111111"/>
+                </a:solidFill>
+                <a:latin typeface="Times New Roman" pitchFamily="34" charset="0"/>
+                <a:ea typeface="Times New Roman" pitchFamily="34" charset="-122"/>
+                <a:cs typeface="Times New Roman" pitchFamily="34" charset="-120"/>
+              </a:rPr>
+              <a:t>It is a long strip of sand joined to the land at one end.</a:t>
             </a:r>
             <a:endParaRPr lang="en-US" sz="4000" dirty="0"/>
           </a:p>
@@ -12692,7 +12764,7 @@
                 <a:ea typeface="Calibri" pitchFamily="34" charset="-122"/>
                 <a:cs typeface="Calibri" pitchFamily="34" charset="-120"/>
               </a:rPr>
-              <a:t>FORMATIVE EVALUATION</a:t>
+              <a:t>BOARD SUMMARY</a:t>
             </a:r>
             <a:endParaRPr lang="en-US" sz="1400" dirty="0"/>
           </a:p>
@@ -12757,7 +12829,7 @@
                 <a:ea typeface="Times New Roman" pitchFamily="34" charset="-122"/>
                 <a:cs typeface="Times New Roman" pitchFamily="34" charset="-120"/>
               </a:rPr>
-              <a:t>Evaluation 1</a:t>
+              <a:t>2. Depositional Features (continued)</a:t>
             </a:r>
             <a:endParaRPr lang="en-US" sz="3600" dirty="0"/>
           </a:p>
@@ -12791,7 +12863,7 @@
               <a:buNone/>
             </a:pPr>
             <a:r>
-              <a:rPr lang="en-US" sz="4000" dirty="0">
+              <a:rPr lang="en-US" sz="4000" b="1" dirty="0">
                 <a:solidFill>
                   <a:srgbClr val="111111"/>
                 </a:solidFill>
@@ -12799,7 +12871,61 @@
                 <a:ea typeface="Times New Roman" pitchFamily="34" charset="-122"/>
                 <a:cs typeface="Times New Roman" pitchFamily="34" charset="-120"/>
               </a:rPr>
-              <a:t>What is longshore drift?</a:t>
+              <a:t>Bar: </a:t>
+            </a:r>
+            <a:pPr algn="l" indent="0" marL="0">
+              <a:spcAft>
+                <a:spcPts val="800"/>
+              </a:spcAft>
+              <a:buNone/>
+            </a:pPr>
+            <a:r>
+              <a:rPr lang="en-US" sz="4000" dirty="0">
+                <a:solidFill>
+                  <a:srgbClr val="111111"/>
+                </a:solidFill>
+                <a:latin typeface="Times New Roman" pitchFamily="34" charset="0"/>
+                <a:ea typeface="Times New Roman" pitchFamily="34" charset="-122"/>
+                <a:cs typeface="Times New Roman" pitchFamily="34" charset="-120"/>
+              </a:rPr>
+              <a:t>It is a strip of sand that grows across a bay.</a:t>
+            </a:r>
+            <a:endParaRPr lang="en-US" sz="4000" dirty="0"/>
+          </a:p>
+          <a:p>
+            <a:pPr algn="l" indent="0" marL="0">
+              <a:spcAft>
+                <a:spcPts val="800"/>
+              </a:spcAft>
+              <a:buNone/>
+            </a:pPr>
+            <a:r>
+              <a:rPr lang="en-US" sz="4000" b="1" dirty="0">
+                <a:solidFill>
+                  <a:srgbClr val="111111"/>
+                </a:solidFill>
+                <a:latin typeface="Times New Roman" pitchFamily="34" charset="0"/>
+                <a:ea typeface="Times New Roman" pitchFamily="34" charset="-122"/>
+                <a:cs typeface="Times New Roman" pitchFamily="34" charset="-120"/>
+              </a:rPr>
+              <a:t>Tombolo: </a:t>
+            </a:r>
+            <a:pPr algn="l" indent="0" marL="0">
+              <a:spcAft>
+                <a:spcPts val="800"/>
+              </a:spcAft>
+              <a:buNone/>
+            </a:pPr>
+            <a:r>
+              <a:rPr lang="en-US" sz="4000" dirty="0">
+                <a:solidFill>
+                  <a:srgbClr val="111111"/>
+                </a:solidFill>
+                <a:latin typeface="Times New Roman" pitchFamily="34" charset="0"/>
+                <a:ea typeface="Times New Roman" pitchFamily="34" charset="-122"/>
+                <a:cs typeface="Times New Roman" pitchFamily="34" charset="-120"/>
+              </a:rPr>
+              <a:t>It is a strip of sand that joins an island to the mainland.</a:t>
             </a:r>
             <a:endParaRPr lang="en-US" sz="4000" dirty="0"/>
           </a:p>
@@ -12976,7 +13102,7 @@
                 <a:ea typeface="Times New Roman" pitchFamily="34" charset="-122"/>
                 <a:cs typeface="Times New Roman" pitchFamily="34" charset="-120"/>
               </a:rPr>
-              <a:t>Expected Answer</a:t>
+              <a:t>Evaluation 1</a:t>
             </a:r>
             <a:endParaRPr lang="en-US" sz="3600" dirty="0"/>
           </a:p>
@@ -13018,7 +13144,7 @@
                 <a:ea typeface="Times New Roman" pitchFamily="34" charset="-122"/>
                 <a:cs typeface="Times New Roman" pitchFamily="34" charset="-120"/>
               </a:rPr>
-              <a:t>The movement of sand along the beach by waves.</a:t>
+              <a:t>What is longshore drift?</a:t>
             </a:r>
             <a:endParaRPr lang="en-US" sz="4000" dirty="0"/>
           </a:p>
@@ -13195,7 +13321,7 @@
                 <a:ea typeface="Times New Roman" pitchFamily="34" charset="-122"/>
                 <a:cs typeface="Times New Roman" pitchFamily="34" charset="-120"/>
               </a:rPr>
-              <a:t>Evaluation 2</a:t>
+              <a:t>Expected Answer</a:t>
             </a:r>
             <a:endParaRPr lang="en-US" sz="3600" dirty="0"/>
           </a:p>
@@ -13237,7 +13363,7 @@
                 <a:ea typeface="Times New Roman" pitchFamily="34" charset="-122"/>
                 <a:cs typeface="Times New Roman" pitchFamily="34" charset="-120"/>
               </a:rPr>
-              <a:t>What is the difference between a spit and a bar?</a:t>
+              <a:t>The movement of sand along the beach by waves.</a:t>
             </a:r>
             <a:endParaRPr lang="en-US" sz="4000" dirty="0"/>
           </a:p>
@@ -13414,7 +13540,7 @@
                 <a:ea typeface="Times New Roman" pitchFamily="34" charset="-122"/>
                 <a:cs typeface="Times New Roman" pitchFamily="34" charset="-120"/>
               </a:rPr>
-              <a:t>Expected Answer</a:t>
+              <a:t>Evaluation 2</a:t>
             </a:r>
             <a:endParaRPr lang="en-US" sz="3600" dirty="0"/>
           </a:p>
@@ -13456,7 +13582,7 @@
                 <a:ea typeface="Times New Roman" pitchFamily="34" charset="-122"/>
                 <a:cs typeface="Times New Roman" pitchFamily="34" charset="-120"/>
               </a:rPr>
-              <a:t>A spit is joined at one end; a bar closes a bay.</a:t>
+              <a:t>What is the difference between a spit and a bar?</a:t>
             </a:r>
             <a:endParaRPr lang="en-US" sz="4000" dirty="0"/>
           </a:p>
@@ -13568,7 +13694,7 @@
                 <a:ea typeface="Calibri" pitchFamily="34" charset="-122"/>
                 <a:cs typeface="Calibri" pitchFamily="34" charset="-120"/>
               </a:rPr>
-              <a:t>REMEDIATION</a:t>
+              <a:t>FORMATIVE EVALUATION</a:t>
             </a:r>
             <a:endParaRPr lang="en-US" sz="1400" dirty="0"/>
           </a:p>
@@ -13633,7 +13759,7 @@
                 <a:ea typeface="Times New Roman" pitchFamily="34" charset="-122"/>
                 <a:cs typeface="Times New Roman" pitchFamily="34" charset="-120"/>
               </a:rPr>
-              <a:t>Remediation</a:t>
+              <a:t>Expected Answer</a:t>
             </a:r>
             <a:endParaRPr lang="en-US" sz="3600" dirty="0"/>
           </a:p>
@@ -13667,7 +13793,7 @@
               <a:buNone/>
             </a:pPr>
             <a:r>
-              <a:rPr lang="en-US" sz="4000" b="1" dirty="0">
+              <a:rPr lang="en-US" sz="4000" dirty="0">
                 <a:solidFill>
                   <a:srgbClr val="111111"/>
                 </a:solidFill>
@@ -13675,51 +13801,7 @@
                 <a:ea typeface="Times New Roman" pitchFamily="34" charset="-122"/>
                 <a:cs typeface="Times New Roman" pitchFamily="34" charset="-120"/>
               </a:rPr>
-              <a:t>Fill in the blanks:</a:t>
-            </a:r>
-            <a:endParaRPr lang="en-US" sz="4000" dirty="0"/>
-          </a:p>
-          <a:p>
-            <a:pPr algn="l" marL="342900" indent="-342900">
-              <a:spcAft>
-                <a:spcPts val="800"/>
-              </a:spcAft>
-              <a:buSzPct val="100000"/>
-              <a:buFont typeface="+mj-lt"/>
-              <a:buAutoNum type="arabicPeriod" startAt="1"/>
-            </a:pPr>
-            <a:r>
-              <a:rPr lang="en-US" sz="4000" dirty="0">
-                <a:solidFill>
-                  <a:srgbClr val="111111"/>
-                </a:solidFill>
-                <a:latin typeface="Times New Roman" pitchFamily="34" charset="0"/>
-                <a:ea typeface="Times New Roman" pitchFamily="34" charset="-122"/>
-                <a:cs typeface="Times New Roman" pitchFamily="34" charset="-120"/>
-              </a:rPr>
-              <a:t>The movement of sand along the beach is ______ drift.</a:t>
-            </a:r>
-            <a:endParaRPr lang="en-US" sz="4000" dirty="0"/>
-          </a:p>
-          <a:p>
-            <a:pPr algn="l" marL="342900" indent="-342900">
-              <a:spcAft>
-                <a:spcPts val="800"/>
-              </a:spcAft>
-              <a:buSzPct val="100000"/>
-              <a:buFont typeface="+mj-lt"/>
-              <a:buAutoNum type="arabicPeriod" startAt="1"/>
-            </a:pPr>
-            <a:r>
-              <a:rPr lang="en-US" sz="4000" dirty="0">
-                <a:solidFill>
-                  <a:srgbClr val="111111"/>
-                </a:solidFill>
-                <a:latin typeface="Times New Roman" pitchFamily="34" charset="0"/>
-                <a:ea typeface="Times New Roman" pitchFamily="34" charset="-122"/>
-                <a:cs typeface="Times New Roman" pitchFamily="34" charset="-120"/>
-              </a:rPr>
-              <a:t>A strip of sand joined at one end is a ______.</a:t>
+              <a:t>A spit is joined at one end; a bar closes a bay.</a:t>
             </a:r>
             <a:endParaRPr lang="en-US" sz="4000" dirty="0"/>
           </a:p>
@@ -13896,7 +13978,7 @@
                 <a:ea typeface="Times New Roman" pitchFamily="34" charset="-122"/>
                 <a:cs typeface="Times New Roman" pitchFamily="34" charset="-120"/>
               </a:rPr>
-              <a:t>Remediation (continued)</a:t>
+              <a:t>Remediation</a:t>
             </a:r>
             <a:endParaRPr lang="en-US" sz="3600" dirty="0"/>
           </a:p>
@@ -13922,6 +14004,26 @@
         <p:txBody>
           <a:bodyPr wrap="square" lIns="0" tIns="0" rIns="0" bIns="0" rtlCol="0" anchor="t"/>
           <a:lstStyle/>
+          <a:p>
+            <a:pPr algn="l" indent="0" marL="0">
+              <a:spcAft>
+                <a:spcPts val="800"/>
+              </a:spcAft>
+              <a:buNone/>
+            </a:pPr>
+            <a:r>
+              <a:rPr lang="en-US" sz="4000" b="1" dirty="0">
+                <a:solidFill>
+                  <a:srgbClr val="111111"/>
+                </a:solidFill>
+                <a:latin typeface="Times New Roman" pitchFamily="34" charset="0"/>
+                <a:ea typeface="Times New Roman" pitchFamily="34" charset="-122"/>
+                <a:cs typeface="Times New Roman" pitchFamily="34" charset="-120"/>
+              </a:rPr>
+              <a:t>Fill in the blanks:</a:t>
+            </a:r>
+            <a:endParaRPr lang="en-US" sz="4000" dirty="0"/>
+          </a:p>
           <a:p>
             <a:pPr algn="l" marL="342900" indent="-342900">
               <a:spcAft>
@@ -13940,7 +14042,29 @@
                 <a:ea typeface="Times New Roman" pitchFamily="34" charset="-122"/>
                 <a:cs typeface="Times New Roman" pitchFamily="34" charset="-120"/>
               </a:rPr>
-              <a:t>Sand joining an island to the land is a ______.</a:t>
+              <a:t>The movement of sand along the beach is ______ drift.</a:t>
+            </a:r>
+            <a:endParaRPr lang="en-US" sz="4000" dirty="0"/>
+          </a:p>
+          <a:p>
+            <a:pPr algn="l" marL="342900" indent="-342900">
+              <a:spcAft>
+                <a:spcPts val="800"/>
+              </a:spcAft>
+              <a:buSzPct val="100000"/>
+              <a:buFont typeface="+mj-lt"/>
+              <a:buAutoNum type="arabicPeriod" startAt="1"/>
+            </a:pPr>
+            <a:r>
+              <a:rPr lang="en-US" sz="4000" dirty="0">
+                <a:solidFill>
+                  <a:srgbClr val="111111"/>
+                </a:solidFill>
+                <a:latin typeface="Times New Roman" pitchFamily="34" charset="0"/>
+                <a:ea typeface="Times New Roman" pitchFamily="34" charset="-122"/>
+                <a:cs typeface="Times New Roman" pitchFamily="34" charset="-120"/>
+              </a:rPr>
+              <a:t>A strip of sand joined at one end is a ______.</a:t>
             </a:r>
             <a:endParaRPr lang="en-US" sz="4000" dirty="0"/>
           </a:p>
@@ -14052,7 +14176,7 @@
                 <a:ea typeface="Calibri" pitchFamily="34" charset="-122"/>
                 <a:cs typeface="Calibri" pitchFamily="34" charset="-120"/>
               </a:rPr>
-              <a:t>HOMEWORK</a:t>
+              <a:t>REMEDIATION</a:t>
             </a:r>
             <a:endParaRPr lang="en-US" sz="1400" dirty="0"/>
           </a:p>
@@ -14117,7 +14241,7 @@
                 <a:ea typeface="Times New Roman" pitchFamily="34" charset="-122"/>
                 <a:cs typeface="Times New Roman" pitchFamily="34" charset="-120"/>
               </a:rPr>
-              <a:t>Homework</a:t>
+              <a:t>Remediation (continued)</a:t>
             </a:r>
             <a:endParaRPr lang="en-US" sz="3600" dirty="0"/>
           </a:p>
@@ -14144,11 +14268,13 @@
           <a:bodyPr wrap="square" lIns="0" tIns="0" rIns="0" bIns="0" rtlCol="0" anchor="t"/>
           <a:lstStyle/>
           <a:p>
-            <a:pPr algn="l" indent="0" marL="0">
+            <a:pPr algn="l" marL="342900" indent="-342900">
               <a:spcAft>
                 <a:spcPts val="800"/>
               </a:spcAft>
-              <a:buNone/>
+              <a:buSzPct val="100000"/>
+              <a:buFont typeface="+mj-lt"/>
+              <a:buAutoNum type="arabicPeriod" startAt="1"/>
             </a:pPr>
             <a:r>
               <a:rPr lang="en-US" sz="4000" dirty="0">
@@ -14159,7 +14285,7 @@
                 <a:ea typeface="Times New Roman" pitchFamily="34" charset="-122"/>
                 <a:cs typeface="Times New Roman" pitchFamily="34" charset="-120"/>
               </a:rPr>
-              <a:t>List five goods sold in the market of Garoua that come from abroad. Ask a trader through which port they entered Cameroon.</a:t>
+              <a:t>Sand joining an island to the land is a ______.</a:t>
             </a:r>
             <a:endParaRPr lang="en-US" sz="4000" dirty="0"/>
           </a:p>
@@ -14510,7 +14636,7 @@
                 <a:ea typeface="Calibri" pitchFamily="34" charset="-122"/>
                 <a:cs typeface="Calibri" pitchFamily="34" charset="-120"/>
               </a:rPr>
-              <a:t>NEXT LESSON</a:t>
+              <a:t>HOMEWORK</a:t>
             </a:r>
             <a:endParaRPr lang="en-US" sz="1400" dirty="0"/>
           </a:p>
@@ -14575,7 +14701,7 @@
                 <a:ea typeface="Times New Roman" pitchFamily="34" charset="-122"/>
                 <a:cs typeface="Times New Roman" pitchFamily="34" charset="-120"/>
               </a:rPr>
-              <a:t>Next Lesson</a:t>
+              <a:t>Homework</a:t>
             </a:r>
             <a:endParaRPr lang="en-US" sz="3600" dirty="0"/>
           </a:p>
@@ -14599,17 +14725,17 @@
           <a:ln/>
         </p:spPr>
         <p:txBody>
-          <a:bodyPr wrap="square" lIns="0" tIns="0" rIns="0" bIns="0" rtlCol="0" anchor="ctr"/>
-          <a:lstStyle/>
-          <a:p>
-            <a:pPr algn="ctr" indent="0" marL="0">
+          <a:bodyPr wrap="square" lIns="0" tIns="0" rIns="0" bIns="0" rtlCol="0" anchor="t"/>
+          <a:lstStyle/>
+          <a:p>
+            <a:pPr algn="l" indent="0" marL="0">
               <a:spcAft>
                 <a:spcPts val="800"/>
               </a:spcAft>
               <a:buNone/>
             </a:pPr>
             <a:r>
-              <a:rPr lang="en-US" sz="4000" b="1" dirty="0">
+              <a:rPr lang="en-US" sz="4000" dirty="0">
                 <a:solidFill>
                   <a:srgbClr val="111111"/>
                 </a:solidFill>
@@ -14617,27 +14743,7 @@
                 <a:ea typeface="Times New Roman" pitchFamily="34" charset="-122"/>
                 <a:cs typeface="Times New Roman" pitchFamily="34" charset="-120"/>
               </a:rPr>
-              <a:t>Our next lesson will be on:</a:t>
-            </a:r>
-            <a:endParaRPr lang="en-US" sz="4000" dirty="0"/>
-          </a:p>
-          <a:p>
-            <a:pPr algn="ctr" indent="0" marL="0">
-              <a:spcAft>
-                <a:spcPts val="800"/>
-              </a:spcAft>
-              <a:buNone/>
-            </a:pPr>
-            <a:r>
-              <a:rPr lang="en-US" sz="4000" b="1" dirty="0">
-                <a:solidFill>
-                  <a:srgbClr val="990011"/>
-                </a:solidFill>
-                <a:latin typeface="Times New Roman" pitchFamily="34" charset="0"/>
-                <a:ea typeface="Times New Roman" pitchFamily="34" charset="-122"/>
-                <a:cs typeface="Times New Roman" pitchFamily="34" charset="-120"/>
-              </a:rPr>
-              <a:t>Lesson 26: Impact of Wave Action on Human Development along Coastal Areas</a:t>
+              <a:t>List five goods sold in the market of Garoua that come from abroad. Ask a trader through which port they entered Cameroon.</a:t>
             </a:r>
             <a:endParaRPr lang="en-US" sz="4000" dirty="0"/>
           </a:p>
@@ -14749,6 +14855,245 @@
                 <a:ea typeface="Calibri" pitchFamily="34" charset="-122"/>
                 <a:cs typeface="Calibri" pitchFamily="34" charset="-120"/>
               </a:rPr>
+              <a:t>NEXT LESSON</a:t>
+            </a:r>
+            <a:endParaRPr lang="en-US" sz="1400" dirty="0"/>
+          </a:p>
+        </p:txBody>
+      </p:sp>
+      <p:pic>
+        <p:nvPicPr>
+          <p:cNvPr id="3" name="Image 0" descr="/home/claude/f4/img/minesec_sheet.png">    </p:cNvPr>
+          <p:cNvPicPr>
+            <a:picLocks noChangeAspect="1"/>
+          </p:cNvPicPr>
+          <p:nvPr/>
+        </p:nvPicPr>
+        <p:blipFill>
+          <a:blip r:embed="rId1"/>
+          <a:stretch>
+            <a:fillRect/>
+          </a:stretch>
+        </p:blipFill>
+        <p:spPr>
+          <a:xfrm>
+            <a:off x="0" y="658368"/>
+            <a:ext cx="5120640" cy="5833872"/>
+          </a:xfrm>
+          <a:prstGeom prst="rect">
+            <a:avLst/>
+          </a:prstGeom>
+        </p:spPr>
+      </p:pic>
+      <p:sp>
+        <p:nvSpPr>
+          <p:cNvPr id="4" name="Text 1"/>
+          <p:cNvSpPr/>
+          <p:nvPr/>
+        </p:nvSpPr>
+        <p:spPr>
+          <a:xfrm>
+            <a:off x="5349240" y="1005840"/>
+            <a:ext cx="6522415" cy="731520"/>
+          </a:xfrm>
+          <a:prstGeom prst="rect">
+            <a:avLst/>
+          </a:prstGeom>
+          <a:noFill/>
+          <a:ln/>
+        </p:spPr>
+        <p:txBody>
+          <a:bodyPr wrap="square" lIns="0" tIns="0" rIns="0" bIns="0" rtlCol="0" anchor="ctr">
+            <a:normAutofit/>
+          </a:bodyPr>
+          <a:lstStyle/>
+          <a:p>
+            <a:pPr algn="ctr" indent="0" marL="0">
+              <a:buNone/>
+            </a:pPr>
+            <a:r>
+              <a:rPr lang="en-US" sz="3600" b="1" dirty="0">
+                <a:solidFill>
+                  <a:srgbClr val="990011"/>
+                </a:solidFill>
+                <a:latin typeface="Times New Roman" pitchFamily="34" charset="0"/>
+                <a:ea typeface="Times New Roman" pitchFamily="34" charset="-122"/>
+                <a:cs typeface="Times New Roman" pitchFamily="34" charset="-120"/>
+              </a:rPr>
+              <a:t>Next Lesson</a:t>
+            </a:r>
+            <a:endParaRPr lang="en-US" sz="3600" dirty="0"/>
+          </a:p>
+        </p:txBody>
+      </p:sp>
+      <p:sp>
+        <p:nvSpPr>
+          <p:cNvPr id="5" name="Text 2"/>
+          <p:cNvSpPr/>
+          <p:nvPr/>
+        </p:nvSpPr>
+        <p:spPr>
+          <a:xfrm>
+            <a:off x="5349240" y="1783080"/>
+            <a:ext cx="6522415" cy="4663440"/>
+          </a:xfrm>
+          <a:prstGeom prst="rect">
+            <a:avLst/>
+          </a:prstGeom>
+          <a:noFill/>
+          <a:ln/>
+        </p:spPr>
+        <p:txBody>
+          <a:bodyPr wrap="square" lIns="0" tIns="0" rIns="0" bIns="0" rtlCol="0" anchor="ctr"/>
+          <a:lstStyle/>
+          <a:p>
+            <a:pPr algn="ctr" indent="0" marL="0">
+              <a:spcAft>
+                <a:spcPts val="800"/>
+              </a:spcAft>
+              <a:buNone/>
+            </a:pPr>
+            <a:r>
+              <a:rPr lang="en-US" sz="4000" b="1" dirty="0">
+                <a:solidFill>
+                  <a:srgbClr val="111111"/>
+                </a:solidFill>
+                <a:latin typeface="Times New Roman" pitchFamily="34" charset="0"/>
+                <a:ea typeface="Times New Roman" pitchFamily="34" charset="-122"/>
+                <a:cs typeface="Times New Roman" pitchFamily="34" charset="-120"/>
+              </a:rPr>
+              <a:t>Our next lesson will be on:</a:t>
+            </a:r>
+            <a:endParaRPr lang="en-US" sz="4000" dirty="0"/>
+          </a:p>
+          <a:p>
+            <a:pPr algn="ctr" indent="0" marL="0">
+              <a:spcAft>
+                <a:spcPts val="800"/>
+              </a:spcAft>
+              <a:buNone/>
+            </a:pPr>
+            <a:r>
+              <a:rPr lang="en-US" sz="4000" b="1" dirty="0">
+                <a:solidFill>
+                  <a:srgbClr val="990011"/>
+                </a:solidFill>
+                <a:latin typeface="Times New Roman" pitchFamily="34" charset="0"/>
+                <a:ea typeface="Times New Roman" pitchFamily="34" charset="-122"/>
+                <a:cs typeface="Times New Roman" pitchFamily="34" charset="-120"/>
+              </a:rPr>
+              <a:t>Lesson 26: Impact of Wave Action on Human Development along Coastal Areas</a:t>
+            </a:r>
+            <a:endParaRPr lang="en-US" sz="4000" dirty="0"/>
+          </a:p>
+        </p:txBody>
+      </p:sp>
+      <p:sp>
+        <p:nvSpPr>
+          <p:cNvPr id="25" name="Slide Number Placeholder 0"/>
+          <p:cNvSpPr>
+            <a:spLocks noGrp="1"/>
+          </p:cNvSpPr>
+          <p:nvPr>
+            <p:ph type="sldNum" sz="quarter" idx="4294967295"/>
+          </p:nvPr>
+        </p:nvSpPr>
+        <p:spPr>
+          <a:xfrm>
+            <a:off x="27432" y="91440"/>
+            <a:ext cx="585216" cy="475488"/>
+          </a:xfrm>
+          <a:prstGeom prst="rect">
+            <a:avLst/>
+          </a:prstGeom>
+          <a:extLst>
+            <a:ext uri="{C572A759-6A51-4108-AA02-DFA0A04FC94B}">
+              <ma14:wrappingTextBoxFlag xmlns:ma14="http://schemas.microsoft.com/office/mac/drawingml/2011/main" val="0"/>
+            </a:ext>
+          </a:extLst>
+        </p:spPr>
+        <p:txBody>
+          <a:bodyPr/>
+          <a:lstStyle>
+            <a:lvl1pPr>
+              <a:defRPr sz="2000">
+                <a:solidFill>
+                  <a:srgbClr val="FFFFFF"/>
+                </a:solidFill>
+                <a:latin typeface="Calibri"/>
+                <a:ea typeface="Calibri"/>
+                <a:cs typeface="Calibri"/>
+              </a:defRPr>
+            </a:lvl1pPr>
+          </a:lstStyle>
+          <a:p>
+            <a:pPr algn="ctr"/>
+            <a:fld id="{F7021451-1387-4CA6-816F-3879F97B5CBC}" type="slidenum">
+              <a:rPr b="1" lang="en-US"/>
+              <a:t>41</a:t>
+            </a:fld>
+            <a:endParaRPr lang="en-US"/>
+          </a:p>
+        </p:txBody>
+      </p:sp>
+    </p:spTree>
+  </p:cSld>
+  <p:clrMapOvr>
+    <a:masterClrMapping/>
+  </p:clrMapOvr>
+</p:sld>
+</file>
+
+<file path=ppt/slides/slide42.xml><?xml version="1.0" encoding="utf-8"?>
+<p:sld xmlns:a="http://schemas.openxmlformats.org/drawingml/2006/main" xmlns:r="http://schemas.openxmlformats.org/officeDocument/2006/relationships" xmlns:p="http://schemas.openxmlformats.org/presentationml/2006/main">
+  <p:cSld name="Slide 42">
+    <p:spTree>
+      <p:nvGrpSpPr>
+        <p:cNvPr id="1" name=""/>
+        <p:cNvGrpSpPr/>
+        <p:nvPr/>
+      </p:nvGrpSpPr>
+      <p:grpSpPr>
+        <a:xfrm>
+          <a:off x="0" y="0"/>
+          <a:ext cx="0" cy="0"/>
+          <a:chOff x="0" y="0"/>
+          <a:chExt cx="0" cy="0"/>
+        </a:xfrm>
+      </p:grpSpPr>
+      <p:sp>
+        <p:nvSpPr>
+          <p:cNvPr id="2" name="Text 0"/>
+          <p:cNvSpPr/>
+          <p:nvPr/>
+        </p:nvSpPr>
+        <p:spPr>
+          <a:xfrm>
+            <a:off x="457200" y="713232"/>
+            <a:ext cx="11368735" cy="274320"/>
+          </a:xfrm>
+          <a:prstGeom prst="rect">
+            <a:avLst/>
+          </a:prstGeom>
+          <a:noFill/>
+          <a:ln/>
+        </p:spPr>
+        <p:txBody>
+          <a:bodyPr wrap="square" lIns="0" tIns="0" rIns="0" bIns="0" rtlCol="0" anchor="ctr"/>
+          <a:lstStyle/>
+          <a:p>
+            <a:pPr algn="r" indent="0" marL="0">
+              <a:buNone/>
+            </a:pPr>
+            <a:r>
+              <a:rPr lang="en-US" sz="1400" b="1" dirty="0">
+                <a:solidFill>
+                  <a:srgbClr val="1C3F6E"/>
+                </a:solidFill>
+                <a:latin typeface="Calibri" pitchFamily="34" charset="0"/>
+                <a:ea typeface="Calibri" pitchFamily="34" charset="-122"/>
+                <a:cs typeface="Calibri" pitchFamily="34" charset="-120"/>
+              </a:rPr>
               <a:t>BILINGUAL GAME</a:t>
             </a:r>
             <a:endParaRPr lang="en-US" sz="1400" dirty="0"/>
@@ -14796,7 +15141,7 @@
       </p:sp>
       <p:graphicFrame>
         <p:nvGraphicFramePr>
-          <p:cNvPr id="42" name="Table 0"/>
+          <p:cNvPr id="43" name="Table 0"/>
           <p:cNvGraphicFramePr>
             <a:graphicFrameLocks noGrp="1"/>
           </p:cNvGraphicFramePr>
@@ -16108,7 +16453,7 @@
             <a:pPr algn="ctr"/>
             <a:fld id="{F7021451-1387-4CA6-816F-3879F97B5CBC}" type="slidenum">
               <a:rPr b="1" lang="en-US"/>
-              <a:t>41</a:t>
+              <a:t>42</a:t>
             </a:fld>
             <a:endParaRPr lang="en-US"/>
           </a:p>
@@ -16122,9 +16467,9 @@
 </p:sld>
 </file>
 
-<file path=ppt/slides/slide42.xml><?xml version="1.0" encoding="utf-8"?>
+<file path=ppt/slides/slide43.xml><?xml version="1.0" encoding="utf-8"?>
 <p:sld xmlns:a="http://schemas.openxmlformats.org/drawingml/2006/main" xmlns:r="http://schemas.openxmlformats.org/officeDocument/2006/relationships" xmlns:p="http://schemas.openxmlformats.org/presentationml/2006/main">
-  <p:cSld name="Slide 42">
+  <p:cSld name="Slide 43">
     <p:spTree>
       <p:nvGrpSpPr>
         <p:cNvPr id="1" name=""/>
@@ -16219,7 +16564,7 @@
       </p:sp>
       <p:graphicFrame>
         <p:nvGraphicFramePr>
-          <p:cNvPr id="43" name="Table 0"/>
+          <p:cNvPr id="44" name="Table 0"/>
           <p:cNvGraphicFramePr>
             <a:graphicFrameLocks noGrp="1"/>
           </p:cNvGraphicFramePr>
@@ -16841,7 +17186,7 @@
             <a:pPr algn="ctr"/>
             <a:fld id="{F7021451-1387-4CA6-816F-3879F97B5CBC}" type="slidenum">
               <a:rPr b="1" lang="en-US"/>
-              <a:t>42</a:t>
+              <a:t>43</a:t>
             </a:fld>
             <a:endParaRPr lang="en-US"/>
           </a:p>
@@ -16855,9 +17200,9 @@
 </p:sld>
 </file>
 
-<file path=ppt/slides/slide43.xml><?xml version="1.0" encoding="utf-8"?>
+<file path=ppt/slides/slide44.xml><?xml version="1.0" encoding="utf-8"?>
 <p:sld xmlns:a="http://schemas.openxmlformats.org/drawingml/2006/main" xmlns:r="http://schemas.openxmlformats.org/officeDocument/2006/relationships" xmlns:p="http://schemas.openxmlformats.org/presentationml/2006/main">
-  <p:cSld name="Slide 43">
+  <p:cSld name="Slide 44">
     <p:spTree>
       <p:nvGrpSpPr>
         <p:cNvPr id="1" name=""/>
@@ -16952,7 +17297,7 @@
       </p:sp>
       <p:graphicFrame>
         <p:nvGraphicFramePr>
-          <p:cNvPr id="44" name="Table 0"/>
+          <p:cNvPr id="45" name="Table 0"/>
           <p:cNvGraphicFramePr>
             <a:graphicFrameLocks noGrp="1"/>
           </p:cNvGraphicFramePr>
@@ -17062,7 +17407,7 @@
                           <a:ea typeface="Calibri" pitchFamily="34" charset="-122"/>
                           <a:cs typeface="Calibri" pitchFamily="34" charset="-120"/>
                         </a:rPr>
-                        <a:t>Longshore Drift; Depositional Features.</a:t>
+                        <a:t>DEFINITIONS; Longshore Drift; Depositional Features.</a:t>
                       </a:r>
                       <a:endParaRPr lang="en-US" sz="1600" dirty="0">
                         <a:latin typeface="Calibri" charset="0"/>
@@ -17712,310 +18057,6 @@
             <a:pPr algn="ctr"/>
             <a:fld id="{F7021451-1387-4CA6-816F-3879F97B5CBC}" type="slidenum">
               <a:rPr b="1" lang="en-US"/>
-              <a:t>43</a:t>
-            </a:fld>
-            <a:endParaRPr lang="en-US"/>
-          </a:p>
-        </p:txBody>
-      </p:sp>
-    </p:spTree>
-  </p:cSld>
-  <p:clrMapOvr>
-    <a:masterClrMapping/>
-  </p:clrMapOvr>
-</p:sld>
-</file>
-
-<file path=ppt/slides/slide44.xml><?xml version="1.0" encoding="utf-8"?>
-<p:sld xmlns:a="http://schemas.openxmlformats.org/drawingml/2006/main" xmlns:r="http://schemas.openxmlformats.org/officeDocument/2006/relationships" xmlns:p="http://schemas.openxmlformats.org/presentationml/2006/main">
-  <p:cSld name="Slide 44">
-    <p:spTree>
-      <p:nvGrpSpPr>
-        <p:cNvPr id="1" name=""/>
-        <p:cNvGrpSpPr/>
-        <p:nvPr/>
-      </p:nvGrpSpPr>
-      <p:grpSpPr>
-        <a:xfrm>
-          <a:off x="0" y="0"/>
-          <a:ext cx="0" cy="0"/>
-          <a:chOff x="0" y="0"/>
-          <a:chExt cx="0" cy="0"/>
-        </a:xfrm>
-      </p:grpSpPr>
-      <p:sp>
-        <p:nvSpPr>
-          <p:cNvPr id="2" name="Text 0"/>
-          <p:cNvSpPr/>
-          <p:nvPr/>
-        </p:nvSpPr>
-        <p:spPr>
-          <a:xfrm>
-            <a:off x="457200" y="713232"/>
-            <a:ext cx="11368735" cy="274320"/>
-          </a:xfrm>
-          <a:prstGeom prst="rect">
-            <a:avLst/>
-          </a:prstGeom>
-          <a:noFill/>
-          <a:ln/>
-        </p:spPr>
-        <p:txBody>
-          <a:bodyPr wrap="square" lIns="0" tIns="0" rIns="0" bIns="0" rtlCol="0" anchor="ctr"/>
-          <a:lstStyle/>
-          <a:p>
-            <a:pPr algn="r" indent="0" marL="0">
-              <a:buNone/>
-            </a:pPr>
-            <a:r>
-              <a:rPr lang="en-US" sz="1400" b="1" dirty="0">
-                <a:solidFill>
-                  <a:srgbClr val="1C3F6E"/>
-                </a:solidFill>
-                <a:latin typeface="Calibri" pitchFamily="34" charset="0"/>
-                <a:ea typeface="Calibri" pitchFamily="34" charset="-122"/>
-                <a:cs typeface="Calibri" pitchFamily="34" charset="-120"/>
-              </a:rPr>
-              <a:t>TEACHER'S NOTE</a:t>
-            </a:r>
-            <a:endParaRPr lang="en-US" sz="1400" dirty="0"/>
-          </a:p>
-        </p:txBody>
-      </p:sp>
-      <p:pic>
-        <p:nvPicPr>
-          <p:cNvPr id="3" name="Image 0" descr="/home/claude/f4/img/minesec_sheet.png">    </p:cNvPr>
-          <p:cNvPicPr>
-            <a:picLocks noChangeAspect="1"/>
-          </p:cNvPicPr>
-          <p:nvPr/>
-        </p:nvPicPr>
-        <p:blipFill>
-          <a:blip r:embed="rId1"/>
-          <a:stretch>
-            <a:fillRect/>
-          </a:stretch>
-        </p:blipFill>
-        <p:spPr>
-          <a:xfrm>
-            <a:off x="0" y="658368"/>
-            <a:ext cx="5120640" cy="5833872"/>
-          </a:xfrm>
-          <a:prstGeom prst="rect">
-            <a:avLst/>
-          </a:prstGeom>
-        </p:spPr>
-      </p:pic>
-      <p:sp>
-        <p:nvSpPr>
-          <p:cNvPr id="4" name="Text 1"/>
-          <p:cNvSpPr/>
-          <p:nvPr/>
-        </p:nvSpPr>
-        <p:spPr>
-          <a:xfrm>
-            <a:off x="5349240" y="1005840"/>
-            <a:ext cx="6522415" cy="731520"/>
-          </a:xfrm>
-          <a:prstGeom prst="rect">
-            <a:avLst/>
-          </a:prstGeom>
-          <a:noFill/>
-          <a:ln/>
-        </p:spPr>
-        <p:txBody>
-          <a:bodyPr wrap="square" lIns="0" tIns="0" rIns="0" bIns="0" rtlCol="0" anchor="ctr">
-            <a:normAutofit/>
-          </a:bodyPr>
-          <a:lstStyle/>
-          <a:p>
-            <a:pPr algn="ctr" indent="0" marL="0">
-              <a:buNone/>
-            </a:pPr>
-            <a:r>
-              <a:rPr lang="en-US" sz="3600" b="1" dirty="0">
-                <a:solidFill>
-                  <a:srgbClr val="990011"/>
-                </a:solidFill>
-                <a:latin typeface="Times New Roman" pitchFamily="34" charset="0"/>
-                <a:ea typeface="Times New Roman" pitchFamily="34" charset="-122"/>
-                <a:cs typeface="Times New Roman" pitchFamily="34" charset="-120"/>
-              </a:rPr>
-              <a:t>Teacher's Note</a:t>
-            </a:r>
-            <a:endParaRPr lang="en-US" sz="3600" dirty="0"/>
-          </a:p>
-        </p:txBody>
-      </p:sp>
-      <p:sp>
-        <p:nvSpPr>
-          <p:cNvPr id="5" name="Text 2"/>
-          <p:cNvSpPr/>
-          <p:nvPr/>
-        </p:nvSpPr>
-        <p:spPr>
-          <a:xfrm>
-            <a:off x="5349240" y="1783080"/>
-            <a:ext cx="6522415" cy="4663440"/>
-          </a:xfrm>
-          <a:prstGeom prst="rect">
-            <a:avLst/>
-          </a:prstGeom>
-          <a:noFill/>
-          <a:ln/>
-        </p:spPr>
-        <p:txBody>
-          <a:bodyPr wrap="square" lIns="0" tIns="0" rIns="0" bIns="0" rtlCol="0" anchor="t"/>
-          <a:lstStyle/>
-          <a:p>
-            <a:pPr algn="l" marL="342900" indent="-342900">
-              <a:spcAft>
-                <a:spcPts val="800"/>
-              </a:spcAft>
-              <a:buSzPct val="100000"/>
-              <a:buChar char="•"/>
-            </a:pPr>
-            <a:r>
-              <a:rPr lang="en-US" sz="2000" dirty="0">
-                <a:solidFill>
-                  <a:srgbClr val="111111"/>
-                </a:solidFill>
-                <a:latin typeface="Calibri" pitchFamily="34" charset="0"/>
-                <a:ea typeface="Calibri" pitchFamily="34" charset="-122"/>
-                <a:cs typeface="Calibri" pitchFamily="34" charset="-120"/>
-              </a:rPr>
-              <a:t>Timing: Homework correction, plan, objectives 4 min | Recall, situation, action 6 min | 3 activities 12 min | Board summary (copying) 15 min | Evaluation, remediation 5 min | Homework, next lesson 3 min | Logbook 5 min</a:t>
-            </a:r>
-            <a:endParaRPr lang="en-US" sz="2000" dirty="0"/>
-          </a:p>
-          <a:p>
-            <a:pPr algn="l" marL="342900" indent="-342900">
-              <a:spcAft>
-                <a:spcPts val="800"/>
-              </a:spcAft>
-              <a:buSzPct val="100000"/>
-              <a:buChar char="•"/>
-            </a:pPr>
-            <a:r>
-              <a:rPr lang="en-US" sz="2000" dirty="0">
-                <a:solidFill>
-                  <a:srgbClr val="111111"/>
-                </a:solidFill>
-                <a:latin typeface="Calibri" pitchFamily="34" charset="0"/>
-                <a:ea typeface="Calibri" pitchFamily="34" charset="-122"/>
-                <a:cs typeface="Calibri" pitchFamily="34" charset="-120"/>
-              </a:rPr>
-              <a:t>Activity 1 is an animation (GIF): it plays automatically in slide-show mode.</a:t>
-            </a:r>
-            <a:endParaRPr lang="en-US" sz="2000" dirty="0"/>
-          </a:p>
-          <a:p>
-            <a:pPr algn="l" marL="342900" indent="-342900">
-              <a:spcAft>
-                <a:spcPts val="800"/>
-              </a:spcAft>
-              <a:buSzPct val="100000"/>
-              <a:buChar char="•"/>
-            </a:pPr>
-            <a:r>
-              <a:rPr lang="en-US" sz="2000" dirty="0">
-                <a:solidFill>
-                  <a:srgbClr val="111111"/>
-                </a:solidFill>
-                <a:latin typeface="Calibri" pitchFamily="34" charset="0"/>
-                <a:ea typeface="Calibri" pitchFamily="34" charset="-122"/>
-                <a:cs typeface="Calibri" pitchFamily="34" charset="-120"/>
-              </a:rPr>
-              <a:t>Without the projector (Activity 1): draw a zigzag line along a beach.</a:t>
-            </a:r>
-            <a:endParaRPr lang="en-US" sz="2000" dirty="0"/>
-          </a:p>
-          <a:p>
-            <a:pPr algn="l" marL="342900" indent="-342900">
-              <a:spcAft>
-                <a:spcPts val="800"/>
-              </a:spcAft>
-              <a:buSzPct val="100000"/>
-              <a:buChar char="•"/>
-            </a:pPr>
-            <a:r>
-              <a:rPr lang="en-US" sz="2000" dirty="0">
-                <a:solidFill>
-                  <a:srgbClr val="111111"/>
-                </a:solidFill>
-                <a:latin typeface="Calibri" pitchFamily="34" charset="0"/>
-                <a:ea typeface="Calibri" pitchFamily="34" charset="-122"/>
-                <a:cs typeface="Calibri" pitchFamily="34" charset="-120"/>
-              </a:rPr>
-              <a:t>Without the projector (Activity 2): draw a coast with a finger of sand.</a:t>
-            </a:r>
-            <a:endParaRPr lang="en-US" sz="2000" dirty="0"/>
-          </a:p>
-          <a:p>
-            <a:pPr algn="l" marL="342900" indent="-342900">
-              <a:spcAft>
-                <a:spcPts val="800"/>
-              </a:spcAft>
-              <a:buSzPct val="100000"/>
-              <a:buChar char="•"/>
-            </a:pPr>
-            <a:r>
-              <a:rPr lang="en-US" sz="2000" dirty="0">
-                <a:solidFill>
-                  <a:srgbClr val="111111"/>
-                </a:solidFill>
-                <a:latin typeface="Calibri" pitchFamily="34" charset="0"/>
-                <a:ea typeface="Calibri" pitchFamily="34" charset="-122"/>
-                <a:cs typeface="Calibri" pitchFamily="34" charset="-120"/>
-              </a:rPr>
-              <a:t>Without the projector (Activity 3): draw an island joined to the coast by sand.</a:t>
-            </a:r>
-            <a:endParaRPr lang="en-US" sz="2000" dirty="0"/>
-          </a:p>
-        </p:txBody>
-      </p:sp>
-      <p:sp>
-        <p:nvSpPr>
-          <p:cNvPr id="25" name="Slide Number Placeholder 0"/>
-          <p:cNvSpPr>
-            <a:spLocks noGrp="1"/>
-          </p:cNvSpPr>
-          <p:nvPr>
-            <p:ph type="sldNum" sz="quarter" idx="4294967295"/>
-          </p:nvPr>
-        </p:nvSpPr>
-        <p:spPr>
-          <a:xfrm>
-            <a:off x="27432" y="91440"/>
-            <a:ext cx="585216" cy="475488"/>
-          </a:xfrm>
-          <a:prstGeom prst="rect">
-            <a:avLst/>
-          </a:prstGeom>
-          <a:extLst>
-            <a:ext uri="{C572A759-6A51-4108-AA02-DFA0A04FC94B}">
-              <ma14:wrappingTextBoxFlag xmlns:ma14="http://schemas.microsoft.com/office/mac/drawingml/2011/main" val="0"/>
-            </a:ext>
-          </a:extLst>
-        </p:spPr>
-        <p:txBody>
-          <a:bodyPr/>
-          <a:lstStyle>
-            <a:lvl1pPr>
-              <a:defRPr sz="2000">
-                <a:solidFill>
-                  <a:srgbClr val="FFFFFF"/>
-                </a:solidFill>
-                <a:latin typeface="Calibri"/>
-                <a:ea typeface="Calibri"/>
-                <a:cs typeface="Calibri"/>
-              </a:defRPr>
-            </a:lvl1pPr>
-          </a:lstStyle>
-          <a:p>
-            <a:pPr algn="ctr"/>
-            <a:fld id="{F7021451-1387-4CA6-816F-3879F97B5CBC}" type="slidenum">
-              <a:rPr b="1" lang="en-US"/>
               <a:t>44</a:t>
             </a:fld>
             <a:endParaRPr lang="en-US"/>
@@ -18080,7 +18121,7 @@
                 <a:ea typeface="Calibri" pitchFamily="34" charset="-122"/>
                 <a:cs typeface="Calibri" pitchFamily="34" charset="-120"/>
               </a:rPr>
-              <a:t>REFERENCES</a:t>
+              <a:t>TEACHER'S NOTE</a:t>
             </a:r>
             <a:endParaRPr lang="en-US" sz="1400" dirty="0"/>
           </a:p>
@@ -18145,7 +18186,7 @@
                 <a:ea typeface="Times New Roman" pitchFamily="34" charset="-122"/>
                 <a:cs typeface="Times New Roman" pitchFamily="34" charset="-120"/>
               </a:rPr>
-              <a:t>References</a:t>
+              <a:t>Teacher's Note</a:t>
             </a:r>
             <a:endParaRPr lang="en-US" sz="3600" dirty="0"/>
           </a:p>
@@ -18180,7 +18221,7 @@
               <a:buChar char="•"/>
             </a:pPr>
             <a:r>
-              <a:rPr lang="en-US" sz="1800" dirty="0">
+              <a:rPr lang="en-US" sz="2000" dirty="0">
                 <a:solidFill>
                   <a:srgbClr val="111111"/>
                 </a:solidFill>
@@ -18188,9 +18229,9 @@
                 <a:ea typeface="Calibri" pitchFamily="34" charset="-122"/>
                 <a:cs typeface="Calibri" pitchFamily="34" charset="-120"/>
               </a:rPr>
-              <a:t>National Geography Syllabus (MINESEC), Form 4 — Denudation Processes, Landforms and Impacts on Man.</a:t>
-            </a:r>
-            <a:endParaRPr lang="en-US" sz="1800" dirty="0"/>
+              <a:t>Timing: Homework correction, plan, objectives 4 min | Recall, situation, action 6 min | 3 activities 12 min | Board summary (copying) 15 min | Evaluation, remediation 5 min | Homework, next lesson 3 min | Logbook 5 min</a:t>
+            </a:r>
+            <a:endParaRPr lang="en-US" sz="2000" dirty="0"/>
           </a:p>
           <a:p>
             <a:pPr algn="l" marL="342900" indent="-342900">
@@ -18201,7 +18242,7 @@
               <a:buChar char="•"/>
             </a:pPr>
             <a:r>
-              <a:rPr lang="en-US" sz="1800" dirty="0">
+              <a:rPr lang="en-US" sz="2000" dirty="0">
                 <a:solidFill>
                   <a:srgbClr val="111111"/>
                 </a:solidFill>
@@ -18209,9 +18250,9 @@
                 <a:ea typeface="Calibri" pitchFamily="34" charset="-122"/>
                 <a:cs typeface="Calibri" pitchFamily="34" charset="-120"/>
               </a:rPr>
-              <a:t>Teacher's lesson notes (Form 4), checked and corrected where necessary.</a:t>
-            </a:r>
-            <a:endParaRPr lang="en-US" sz="1800" dirty="0"/>
+              <a:t>Activity 1 is an animation (GIF): it plays automatically in slide-show mode.</a:t>
+            </a:r>
+            <a:endParaRPr lang="en-US" sz="2000" dirty="0"/>
           </a:p>
           <a:p>
             <a:pPr algn="l" marL="342900" indent="-342900">
@@ -18222,7 +18263,7 @@
               <a:buChar char="•"/>
             </a:pPr>
             <a:r>
-              <a:rPr lang="en-US" sz="1800" dirty="0">
+              <a:rPr lang="en-US" sz="2000" dirty="0">
                 <a:solidFill>
                   <a:srgbClr val="111111"/>
                 </a:solidFill>
@@ -18230,9 +18271,9 @@
                 <a:ea typeface="Calibri" pitchFamily="34" charset="-122"/>
                 <a:cs typeface="Calibri" pitchFamily="34" charset="-120"/>
               </a:rPr>
-              <a:t>Photo, Activity 2: “Coastal defences no longer being maintained - Why? Spurn Head, Yorkshi” by Richard Allaway, CC BY 2.0, via Flickr (https://www.flickr.com/photos/16287002@N00/6605676971)</a:t>
-            </a:r>
-            <a:endParaRPr lang="en-US" sz="1800" dirty="0"/>
+              <a:t>Without the projector (Activity 1): draw a zigzag line along a beach.</a:t>
+            </a:r>
+            <a:endParaRPr lang="en-US" sz="2000" dirty="0"/>
           </a:p>
           <a:p>
             <a:pPr algn="l" marL="342900" indent="-342900">
@@ -18243,7 +18284,7 @@
               <a:buChar char="•"/>
             </a:pPr>
             <a:r>
-              <a:rPr lang="en-US" sz="1800" dirty="0">
+              <a:rPr lang="en-US" sz="2000" dirty="0">
                 <a:solidFill>
                   <a:srgbClr val="111111"/>
                 </a:solidFill>
@@ -18251,9 +18292,9 @@
                 <a:ea typeface="Calibri" pitchFamily="34" charset="-122"/>
                 <a:cs typeface="Calibri" pitchFamily="34" charset="-120"/>
               </a:rPr>
-              <a:t>Photo, Activity 3: “2017_04_10_lhr-ewr_083” by dsearls, CC BY 2.0, via Flickr (https://www.flickr.com/photos/52614599@N00/33953233846)</a:t>
-            </a:r>
-            <a:endParaRPr lang="en-US" sz="1800" dirty="0"/>
+              <a:t>Without the projector (Activity 2): draw a coast with a finger of sand.</a:t>
+            </a:r>
+            <a:endParaRPr lang="en-US" sz="2000" dirty="0"/>
           </a:p>
           <a:p>
             <a:pPr algn="l" marL="342900" indent="-342900">
@@ -18264,7 +18305,7 @@
               <a:buChar char="•"/>
             </a:pPr>
             <a:r>
-              <a:rPr lang="en-US" sz="1800" dirty="0">
+              <a:rPr lang="en-US" sz="2000" dirty="0">
                 <a:solidFill>
                   <a:srgbClr val="111111"/>
                 </a:solidFill>
@@ -18272,9 +18313,9 @@
                 <a:ea typeface="Calibri" pitchFamily="34" charset="-122"/>
                 <a:cs typeface="Calibri" pitchFamily="34" charset="-120"/>
               </a:rPr>
-              <a:t>Diagrams and animations: drawn for this lesson (Geography Department).</a:t>
-            </a:r>
-            <a:endParaRPr lang="en-US" sz="1800" dirty="0"/>
+              <a:t>Without the projector (Activity 3): draw an island joined to the coast by sand.</a:t>
+            </a:r>
+            <a:endParaRPr lang="en-US" sz="2000" dirty="0"/>
           </a:p>
         </p:txBody>
       </p:sp>
@@ -18321,6 +18362,310 @@
             <a:fld id="{F7021451-1387-4CA6-816F-3879F97B5CBC}" type="slidenum">
               <a:rPr b="1" lang="en-US"/>
               <a:t>45</a:t>
+            </a:fld>
+            <a:endParaRPr lang="en-US"/>
+          </a:p>
+        </p:txBody>
+      </p:sp>
+    </p:spTree>
+  </p:cSld>
+  <p:clrMapOvr>
+    <a:masterClrMapping/>
+  </p:clrMapOvr>
+</p:sld>
+</file>
+
+<file path=ppt/slides/slide46.xml><?xml version="1.0" encoding="utf-8"?>
+<p:sld xmlns:a="http://schemas.openxmlformats.org/drawingml/2006/main" xmlns:r="http://schemas.openxmlformats.org/officeDocument/2006/relationships" xmlns:p="http://schemas.openxmlformats.org/presentationml/2006/main">
+  <p:cSld name="Slide 46">
+    <p:spTree>
+      <p:nvGrpSpPr>
+        <p:cNvPr id="1" name=""/>
+        <p:cNvGrpSpPr/>
+        <p:nvPr/>
+      </p:nvGrpSpPr>
+      <p:grpSpPr>
+        <a:xfrm>
+          <a:off x="0" y="0"/>
+          <a:ext cx="0" cy="0"/>
+          <a:chOff x="0" y="0"/>
+          <a:chExt cx="0" cy="0"/>
+        </a:xfrm>
+      </p:grpSpPr>
+      <p:sp>
+        <p:nvSpPr>
+          <p:cNvPr id="2" name="Text 0"/>
+          <p:cNvSpPr/>
+          <p:nvPr/>
+        </p:nvSpPr>
+        <p:spPr>
+          <a:xfrm>
+            <a:off x="457200" y="713232"/>
+            <a:ext cx="11368735" cy="274320"/>
+          </a:xfrm>
+          <a:prstGeom prst="rect">
+            <a:avLst/>
+          </a:prstGeom>
+          <a:noFill/>
+          <a:ln/>
+        </p:spPr>
+        <p:txBody>
+          <a:bodyPr wrap="square" lIns="0" tIns="0" rIns="0" bIns="0" rtlCol="0" anchor="ctr"/>
+          <a:lstStyle/>
+          <a:p>
+            <a:pPr algn="r" indent="0" marL="0">
+              <a:buNone/>
+            </a:pPr>
+            <a:r>
+              <a:rPr lang="en-US" sz="1400" b="1" dirty="0">
+                <a:solidFill>
+                  <a:srgbClr val="1C3F6E"/>
+                </a:solidFill>
+                <a:latin typeface="Calibri" pitchFamily="34" charset="0"/>
+                <a:ea typeface="Calibri" pitchFamily="34" charset="-122"/>
+                <a:cs typeface="Calibri" pitchFamily="34" charset="-120"/>
+              </a:rPr>
+              <a:t>REFERENCES</a:t>
+            </a:r>
+            <a:endParaRPr lang="en-US" sz="1400" dirty="0"/>
+          </a:p>
+        </p:txBody>
+      </p:sp>
+      <p:pic>
+        <p:nvPicPr>
+          <p:cNvPr id="3" name="Image 0" descr="/home/claude/f4/img/minesec_sheet.png">    </p:cNvPr>
+          <p:cNvPicPr>
+            <a:picLocks noChangeAspect="1"/>
+          </p:cNvPicPr>
+          <p:nvPr/>
+        </p:nvPicPr>
+        <p:blipFill>
+          <a:blip r:embed="rId1"/>
+          <a:stretch>
+            <a:fillRect/>
+          </a:stretch>
+        </p:blipFill>
+        <p:spPr>
+          <a:xfrm>
+            <a:off x="0" y="658368"/>
+            <a:ext cx="5120640" cy="5833872"/>
+          </a:xfrm>
+          <a:prstGeom prst="rect">
+            <a:avLst/>
+          </a:prstGeom>
+        </p:spPr>
+      </p:pic>
+      <p:sp>
+        <p:nvSpPr>
+          <p:cNvPr id="4" name="Text 1"/>
+          <p:cNvSpPr/>
+          <p:nvPr/>
+        </p:nvSpPr>
+        <p:spPr>
+          <a:xfrm>
+            <a:off x="5349240" y="1005840"/>
+            <a:ext cx="6522415" cy="731520"/>
+          </a:xfrm>
+          <a:prstGeom prst="rect">
+            <a:avLst/>
+          </a:prstGeom>
+          <a:noFill/>
+          <a:ln/>
+        </p:spPr>
+        <p:txBody>
+          <a:bodyPr wrap="square" lIns="0" tIns="0" rIns="0" bIns="0" rtlCol="0" anchor="ctr">
+            <a:normAutofit/>
+          </a:bodyPr>
+          <a:lstStyle/>
+          <a:p>
+            <a:pPr algn="ctr" indent="0" marL="0">
+              <a:buNone/>
+            </a:pPr>
+            <a:r>
+              <a:rPr lang="en-US" sz="3600" b="1" dirty="0">
+                <a:solidFill>
+                  <a:srgbClr val="990011"/>
+                </a:solidFill>
+                <a:latin typeface="Times New Roman" pitchFamily="34" charset="0"/>
+                <a:ea typeface="Times New Roman" pitchFamily="34" charset="-122"/>
+                <a:cs typeface="Times New Roman" pitchFamily="34" charset="-120"/>
+              </a:rPr>
+              <a:t>References</a:t>
+            </a:r>
+            <a:endParaRPr lang="en-US" sz="3600" dirty="0"/>
+          </a:p>
+        </p:txBody>
+      </p:sp>
+      <p:sp>
+        <p:nvSpPr>
+          <p:cNvPr id="5" name="Text 2"/>
+          <p:cNvSpPr/>
+          <p:nvPr/>
+        </p:nvSpPr>
+        <p:spPr>
+          <a:xfrm>
+            <a:off x="5349240" y="1783080"/>
+            <a:ext cx="6522415" cy="4663440"/>
+          </a:xfrm>
+          <a:prstGeom prst="rect">
+            <a:avLst/>
+          </a:prstGeom>
+          <a:noFill/>
+          <a:ln/>
+        </p:spPr>
+        <p:txBody>
+          <a:bodyPr wrap="square" lIns="0" tIns="0" rIns="0" bIns="0" rtlCol="0" anchor="t"/>
+          <a:lstStyle/>
+          <a:p>
+            <a:pPr algn="l" marL="342900" indent="-342900">
+              <a:spcAft>
+                <a:spcPts val="800"/>
+              </a:spcAft>
+              <a:buSzPct val="100000"/>
+              <a:buChar char="•"/>
+            </a:pPr>
+            <a:r>
+              <a:rPr lang="en-US" sz="1800" dirty="0">
+                <a:solidFill>
+                  <a:srgbClr val="111111"/>
+                </a:solidFill>
+                <a:latin typeface="Calibri" pitchFamily="34" charset="0"/>
+                <a:ea typeface="Calibri" pitchFamily="34" charset="-122"/>
+                <a:cs typeface="Calibri" pitchFamily="34" charset="-120"/>
+              </a:rPr>
+              <a:t>National Geography Syllabus (MINESEC), Form 4 — Denudation Processes, Landforms and Impacts on Man.</a:t>
+            </a:r>
+            <a:endParaRPr lang="en-US" sz="1800" dirty="0"/>
+          </a:p>
+          <a:p>
+            <a:pPr algn="l" marL="342900" indent="-342900">
+              <a:spcAft>
+                <a:spcPts val="800"/>
+              </a:spcAft>
+              <a:buSzPct val="100000"/>
+              <a:buChar char="•"/>
+            </a:pPr>
+            <a:r>
+              <a:rPr lang="en-US" sz="1800" dirty="0">
+                <a:solidFill>
+                  <a:srgbClr val="111111"/>
+                </a:solidFill>
+                <a:latin typeface="Calibri" pitchFamily="34" charset="0"/>
+                <a:ea typeface="Calibri" pitchFamily="34" charset="-122"/>
+                <a:cs typeface="Calibri" pitchFamily="34" charset="-120"/>
+              </a:rPr>
+              <a:t>Teacher's lesson notes (Form 4), checked and corrected where necessary.</a:t>
+            </a:r>
+            <a:endParaRPr lang="en-US" sz="1800" dirty="0"/>
+          </a:p>
+          <a:p>
+            <a:pPr algn="l" marL="342900" indent="-342900">
+              <a:spcAft>
+                <a:spcPts val="800"/>
+              </a:spcAft>
+              <a:buSzPct val="100000"/>
+              <a:buChar char="•"/>
+            </a:pPr>
+            <a:r>
+              <a:rPr lang="en-US" sz="1800" dirty="0">
+                <a:solidFill>
+                  <a:srgbClr val="111111"/>
+                </a:solidFill>
+                <a:latin typeface="Calibri" pitchFamily="34" charset="0"/>
+                <a:ea typeface="Calibri" pitchFamily="34" charset="-122"/>
+                <a:cs typeface="Calibri" pitchFamily="34" charset="-120"/>
+              </a:rPr>
+              <a:t>Photo, Activity 2: “Coastal defences no longer being maintained - Why? Spurn Head, Yorkshi” by Richard Allaway, CC BY 2.0, via Flickr (https://www.flickr.com/photos/16287002@N00/6605676971)</a:t>
+            </a:r>
+            <a:endParaRPr lang="en-US" sz="1800" dirty="0"/>
+          </a:p>
+          <a:p>
+            <a:pPr algn="l" marL="342900" indent="-342900">
+              <a:spcAft>
+                <a:spcPts val="800"/>
+              </a:spcAft>
+              <a:buSzPct val="100000"/>
+              <a:buChar char="•"/>
+            </a:pPr>
+            <a:r>
+              <a:rPr lang="en-US" sz="1800" dirty="0">
+                <a:solidFill>
+                  <a:srgbClr val="111111"/>
+                </a:solidFill>
+                <a:latin typeface="Calibri" pitchFamily="34" charset="0"/>
+                <a:ea typeface="Calibri" pitchFamily="34" charset="-122"/>
+                <a:cs typeface="Calibri" pitchFamily="34" charset="-120"/>
+              </a:rPr>
+              <a:t>Photo, Activity 3: “2017_04_10_lhr-ewr_083” by dsearls, CC BY 2.0, via Flickr (https://www.flickr.com/photos/52614599@N00/33953233846)</a:t>
+            </a:r>
+            <a:endParaRPr lang="en-US" sz="1800" dirty="0"/>
+          </a:p>
+          <a:p>
+            <a:pPr algn="l" marL="342900" indent="-342900">
+              <a:spcAft>
+                <a:spcPts val="800"/>
+              </a:spcAft>
+              <a:buSzPct val="100000"/>
+              <a:buChar char="•"/>
+            </a:pPr>
+            <a:r>
+              <a:rPr lang="en-US" sz="1800" dirty="0">
+                <a:solidFill>
+                  <a:srgbClr val="111111"/>
+                </a:solidFill>
+                <a:latin typeface="Calibri" pitchFamily="34" charset="0"/>
+                <a:ea typeface="Calibri" pitchFamily="34" charset="-122"/>
+                <a:cs typeface="Calibri" pitchFamily="34" charset="-120"/>
+              </a:rPr>
+              <a:t>Diagrams and animations: drawn for this lesson (Geography Department).</a:t>
+            </a:r>
+            <a:endParaRPr lang="en-US" sz="1800" dirty="0"/>
+          </a:p>
+        </p:txBody>
+      </p:sp>
+      <p:sp>
+        <p:nvSpPr>
+          <p:cNvPr id="25" name="Slide Number Placeholder 0"/>
+          <p:cNvSpPr>
+            <a:spLocks noGrp="1"/>
+          </p:cNvSpPr>
+          <p:nvPr>
+            <p:ph type="sldNum" sz="quarter" idx="4294967295"/>
+          </p:nvPr>
+        </p:nvSpPr>
+        <p:spPr>
+          <a:xfrm>
+            <a:off x="27432" y="91440"/>
+            <a:ext cx="585216" cy="475488"/>
+          </a:xfrm>
+          <a:prstGeom prst="rect">
+            <a:avLst/>
+          </a:prstGeom>
+          <a:extLst>
+            <a:ext uri="{C572A759-6A51-4108-AA02-DFA0A04FC94B}">
+              <ma14:wrappingTextBoxFlag xmlns:ma14="http://schemas.microsoft.com/office/mac/drawingml/2011/main" val="0"/>
+            </a:ext>
+          </a:extLst>
+        </p:spPr>
+        <p:txBody>
+          <a:bodyPr/>
+          <a:lstStyle>
+            <a:lvl1pPr>
+              <a:defRPr sz="2000">
+                <a:solidFill>
+                  <a:srgbClr val="FFFFFF"/>
+                </a:solidFill>
+                <a:latin typeface="Calibri"/>
+                <a:ea typeface="Calibri"/>
+                <a:cs typeface="Calibri"/>
+              </a:defRPr>
+            </a:lvl1pPr>
+          </a:lstStyle>
+          <a:p>
+            <a:pPr algn="ctr"/>
+            <a:fld id="{F7021451-1387-4CA6-816F-3879F97B5CBC}" type="slidenum">
+              <a:rPr b="1" lang="en-US"/>
+              <a:t>46</a:t>
             </a:fld>
             <a:endParaRPr lang="en-US"/>
           </a:p>

</xml_diff>